<commit_message>
project proposal presentation update
</commit_message>
<xml_diff>
--- a/Proposal/Workout (Fitness) Proposal.pptx
+++ b/Proposal/Workout (Fitness) Proposal.pptx
@@ -4,9 +4,6 @@
   <p:sldMasterIdLst>
     <p:sldMasterId id="2147483648" r:id="rId1"/>
   </p:sldMasterIdLst>
-  <p:notesMasterIdLst>
-    <p:notesMasterId r:id="rId10"/>
-  </p:notesMasterIdLst>
   <p:sldIdLst>
     <p:sldId id="256" r:id="rId2"/>
     <p:sldId id="257" r:id="rId3"/>
@@ -17,6 +14,9 @@
     <p:sldId id="262" r:id="rId8"/>
     <p:sldId id="263" r:id="rId9"/>
   </p:sldIdLst>
+  <p:notesMasterIdLst>
+    <p:notesMasterId r:id="rId10"/>
+  </p:notesMasterIdLst>
   <p:sldSz cx="12192000" cy="6858000"/>
   <p:notesSz cx="6858000" cy="12192000"/>
   <p:defaultTextStyle>
@@ -111,11 +111,6 @@
       </a:defRPr>
     </a:lvl9pPr>
   </p:defaultTextStyle>
-  <p:extLst>
-    <p:ext uri="{EFAFB233-063F-42B5-8137-9DF3F51BA10A}">
-      <p15:sldGuideLst xmlns:p15="http://schemas.microsoft.com/office/powerpoint/2012/main"/>
-    </p:ext>
-  </p:extLst>
 </p:presentation>
 </file>
 
@@ -141,10 +136,234 @@
           <a:chExt cx="0" cy="0"/>
         </a:xfrm>
       </p:grpSpPr>
+      <p:sp>
+        <p:nvSpPr>
+          <p:cNvPr id="2" name="Header Placeholder 1"/>
+          <p:cNvSpPr>
+            <a:spLocks noGrp="1"/>
+          </p:cNvSpPr>
+          <p:nvPr>
+            <p:ph type="hdr" sz="quarter"/>
+          </p:nvPr>
+        </p:nvSpPr>
+        <p:spPr>
+          <a:xfrm>
+            <a:off x="0" y="0"/>
+            <a:ext cx="2971800" cy="458788"/>
+          </a:xfrm>
+          <a:prstGeom prst="rect">
+            <a:avLst/>
+          </a:prstGeom>
+        </p:spPr>
+        <p:txBody>
+          <a:bodyPr vert="horz" lIns="91440" tIns="45720" rIns="91440" bIns="45720" rtlCol="0"/>
+          <a:lstStyle>
+            <a:lvl1pPr algn="l">
+              <a:defRPr sz="1200"/>
+            </a:lvl1pPr>
+          </a:lstStyle>
+          <a:p>
+            <a:endParaRPr lang="en-US"/>
+          </a:p>
+        </p:txBody>
+      </p:sp>
+      <p:sp>
+        <p:nvSpPr>
+          <p:cNvPr id="3" name="Date Placeholder 2"/>
+          <p:cNvSpPr>
+            <a:spLocks noGrp="1"/>
+          </p:cNvSpPr>
+          <p:nvPr>
+            <p:ph type="dt" idx="1"/>
+          </p:nvPr>
+        </p:nvSpPr>
+        <p:spPr>
+          <a:xfrm>
+            <a:off x="3884613" y="0"/>
+            <a:ext cx="2971800" cy="458788"/>
+          </a:xfrm>
+          <a:prstGeom prst="rect">
+            <a:avLst/>
+          </a:prstGeom>
+        </p:spPr>
+        <p:txBody>
+          <a:bodyPr vert="horz" lIns="91440" tIns="45720" rIns="91440" bIns="45720" rtlCol="0"/>
+          <a:lstStyle>
+            <a:lvl1pPr algn="r">
+              <a:defRPr sz="1200"/>
+            </a:lvl1pPr>
+          </a:lstStyle>
+          <a:p>
+            <a:fld id="{5282F153-3F37-0F45-9E97-73ACFA13230C}" type="datetimeFigureOut">
+              <a:rPr lang="en-US"/>
+              <a:t>7/23/19</a:t>
+            </a:fld>
+            <a:endParaRPr lang="en-US"/>
+          </a:p>
+        </p:txBody>
+      </p:sp>
+      <p:sp>
+        <p:nvSpPr>
+          <p:cNvPr id="4" name="Slide Image Placeholder 3"/>
+          <p:cNvSpPr>
+            <a:spLocks noGrp="1" noRot="1" noChangeAspect="1"/>
+          </p:cNvSpPr>
+          <p:nvPr>
+            <p:ph type="sldImg" idx="2"/>
+          </p:nvPr>
+        </p:nvSpPr>
+        <p:spPr>
+          <a:xfrm>
+            <a:off x="685800" y="1143000"/>
+            <a:ext cx="5486400" cy="3086100"/>
+          </a:xfrm>
+          <a:prstGeom prst="rect">
+            <a:avLst/>
+          </a:prstGeom>
+          <a:noFill/>
+          <a:ln w="12700">
+            <a:solidFill>
+              <a:prstClr val="black"/>
+            </a:solidFill>
+          </a:ln>
+        </p:spPr>
+        <p:txBody>
+          <a:bodyPr vert="horz" lIns="91440" tIns="45720" rIns="91440" bIns="45720" rtlCol="0" anchor="ctr"/>
+          <a:lstStyle/>
+          <a:p>
+            <a:endParaRPr lang="en-US"/>
+          </a:p>
+        </p:txBody>
+      </p:sp>
+      <p:sp>
+        <p:nvSpPr>
+          <p:cNvPr id="5" name="Notes Placeholder 4"/>
+          <p:cNvSpPr>
+            <a:spLocks noGrp="1"/>
+          </p:cNvSpPr>
+          <p:nvPr>
+            <p:ph type="body" sz="quarter" idx="3"/>
+          </p:nvPr>
+        </p:nvSpPr>
+        <p:spPr>
+          <a:xfrm>
+            <a:off x="685800" y="4400550"/>
+            <a:ext cx="5486400" cy="3600450"/>
+          </a:xfrm>
+          <a:prstGeom prst="rect">
+            <a:avLst/>
+          </a:prstGeom>
+        </p:spPr>
+        <p:txBody>
+          <a:bodyPr vert="horz" lIns="91440" tIns="45720" rIns="91440" bIns="45720" rtlCol="0"/>
+          <a:lstStyle/>
+          <a:p>
+            <a:pPr lvl="0"/>
+            <a:r>
+              <a:rPr lang="en-US"/>
+              <a:t>Click to edit Master text styles</a:t>
+            </a:r>
+          </a:p>
+          <a:p>
+            <a:pPr lvl="1"/>
+            <a:r>
+              <a:rPr lang="en-US"/>
+              <a:t>Second level</a:t>
+            </a:r>
+          </a:p>
+          <a:p>
+            <a:pPr lvl="2"/>
+            <a:r>
+              <a:rPr lang="en-US"/>
+              <a:t>Third level</a:t>
+            </a:r>
+          </a:p>
+          <a:p>
+            <a:pPr lvl="3"/>
+            <a:r>
+              <a:rPr lang="en-US"/>
+              <a:t>Fourth level</a:t>
+            </a:r>
+          </a:p>
+          <a:p>
+            <a:pPr lvl="4"/>
+            <a:r>
+              <a:rPr lang="en-US"/>
+              <a:t>Fifth level</a:t>
+            </a:r>
+          </a:p>
+        </p:txBody>
+      </p:sp>
+      <p:sp>
+        <p:nvSpPr>
+          <p:cNvPr id="6" name="Footer Placeholder 5"/>
+          <p:cNvSpPr>
+            <a:spLocks noGrp="1"/>
+          </p:cNvSpPr>
+          <p:nvPr>
+            <p:ph type="ftr" sz="quarter" idx="4"/>
+          </p:nvPr>
+        </p:nvSpPr>
+        <p:spPr>
+          <a:xfrm>
+            <a:off x="0" y="8685213"/>
+            <a:ext cx="2971800" cy="458787"/>
+          </a:xfrm>
+          <a:prstGeom prst="rect">
+            <a:avLst/>
+          </a:prstGeom>
+        </p:spPr>
+        <p:txBody>
+          <a:bodyPr vert="horz" lIns="91440" tIns="45720" rIns="91440" bIns="45720" rtlCol="0" anchor="b"/>
+          <a:lstStyle>
+            <a:lvl1pPr algn="l">
+              <a:defRPr sz="1200"/>
+            </a:lvl1pPr>
+          </a:lstStyle>
+          <a:p>
+            <a:endParaRPr lang="en-US"/>
+          </a:p>
+        </p:txBody>
+      </p:sp>
+      <p:sp>
+        <p:nvSpPr>
+          <p:cNvPr id="7" name="Slide Number Placeholder 6"/>
+          <p:cNvSpPr>
+            <a:spLocks noGrp="1"/>
+          </p:cNvSpPr>
+          <p:nvPr>
+            <p:ph type="sldNum" sz="quarter" idx="5"/>
+          </p:nvPr>
+        </p:nvSpPr>
+        <p:spPr>
+          <a:xfrm>
+            <a:off x="3884613" y="8685213"/>
+            <a:ext cx="2971800" cy="458787"/>
+          </a:xfrm>
+          <a:prstGeom prst="rect">
+            <a:avLst/>
+          </a:prstGeom>
+        </p:spPr>
+        <p:txBody>
+          <a:bodyPr vert="horz" lIns="91440" tIns="45720" rIns="91440" bIns="45720" rtlCol="0" anchor="b"/>
+          <a:lstStyle>
+            <a:lvl1pPr algn="r">
+              <a:defRPr sz="1200"/>
+            </a:lvl1pPr>
+          </a:lstStyle>
+          <a:p>
+            <a:fld id="{CE5E9CC1-C706-0F49-92D6-E571CC5EEA8F}" type="slidenum">
+              <a:rPr lang="en-US"/>
+              <a:t>‹#›</a:t>
+            </a:fld>
+            <a:endParaRPr lang="en-US"/>
+          </a:p>
+        </p:txBody>
+      </p:sp>
     </p:spTree>
     <p:extLst>
       <p:ext uri="{BB962C8B-B14F-4D97-AF65-F5344CB8AC3E}">
-        <p14:creationId xmlns:p14="http://schemas.microsoft.com/office/powerpoint/2010/main" val="113383449"/>
+        <p14:creationId xmlns:p14="http://schemas.microsoft.com/office/powerpoint/2010/main" val="1024086991"/>
       </p:ext>
     </p:extLst>
   </p:cSld>
@@ -288,6 +507,10 @@
           <a:bodyPr/>
           <a:lstStyle/>
           <a:p>
+            <a:r>
+              <a:rPr lang="en-US" dirty="0"/>
+              <a:t/>
+            </a:r>
             <a:endParaRPr lang="en-US" dirty="0"/>
           </a:p>
         </p:txBody>
@@ -372,6 +595,10 @@
           <a:bodyPr/>
           <a:lstStyle/>
           <a:p>
+            <a:r>
+              <a:rPr lang="en-US" dirty="0"/>
+              <a:t/>
+            </a:r>
             <a:endParaRPr lang="en-US" dirty="0"/>
           </a:p>
         </p:txBody>
@@ -456,6 +683,10 @@
           <a:bodyPr/>
           <a:lstStyle/>
           <a:p>
+            <a:r>
+              <a:rPr lang="en-US" dirty="0"/>
+              <a:t/>
+            </a:r>
             <a:endParaRPr lang="en-US" dirty="0"/>
           </a:p>
         </p:txBody>
@@ -540,6 +771,10 @@
           <a:bodyPr/>
           <a:lstStyle/>
           <a:p>
+            <a:r>
+              <a:rPr lang="en-US" dirty="0"/>
+              <a:t/>
+            </a:r>
             <a:endParaRPr lang="en-US" dirty="0"/>
           </a:p>
         </p:txBody>
@@ -624,6 +859,10 @@
           <a:bodyPr/>
           <a:lstStyle/>
           <a:p>
+            <a:r>
+              <a:rPr lang="en-US" dirty="0"/>
+              <a:t/>
+            </a:r>
             <a:endParaRPr lang="en-US" dirty="0"/>
           </a:p>
         </p:txBody>
@@ -708,6 +947,10 @@
           <a:bodyPr/>
           <a:lstStyle/>
           <a:p>
+            <a:r>
+              <a:rPr lang="en-US" dirty="0"/>
+              <a:t/>
+            </a:r>
             <a:endParaRPr lang="en-US" dirty="0"/>
           </a:p>
         </p:txBody>
@@ -792,6 +1035,10 @@
           <a:bodyPr/>
           <a:lstStyle/>
           <a:p>
+            <a:r>
+              <a:rPr lang="en-US" dirty="0"/>
+              <a:t/>
+            </a:r>
             <a:endParaRPr lang="en-US" dirty="0"/>
           </a:p>
         </p:txBody>
@@ -876,6 +1123,10 @@
           <a:bodyPr/>
           <a:lstStyle/>
           <a:p>
+            <a:r>
+              <a:rPr lang="en-US" dirty="0"/>
+              <a:t/>
+            </a:r>
             <a:endParaRPr lang="en-US" dirty="0"/>
           </a:p>
         </p:txBody>
@@ -949,11 +1200,6 @@
 <file path=ppt/slideMasters/slideMaster1.xml><?xml version="1.0" encoding="utf-8"?>
 <p:sldMaster xmlns:a="http://schemas.openxmlformats.org/drawingml/2006/main" xmlns:r="http://schemas.openxmlformats.org/officeDocument/2006/relationships" xmlns:p="http://schemas.openxmlformats.org/presentationml/2006/main">
   <p:cSld>
-    <p:bg>
-      <p:bgRef idx="1001">
-        <a:schemeClr val="bg1"/>
-      </p:bgRef>
-    </p:bg>
     <p:spTree>
       <p:nvGrpSpPr>
         <p:cNvPr id="1" name=""/>
@@ -1236,7 +1482,6 @@
         <a:solidFill>
           <a:srgbClr val="14181F"/>
         </a:solidFill>
-        <a:effectLst/>
       </p:bgPr>
     </p:bg>
     <p:spTree>
@@ -1255,15 +1500,15 @@
       </p:grpSpPr>
       <p:pic>
         <p:nvPicPr>
-          <p:cNvPr id="2" name="Image 0" descr="Man doing a dumbbell curl in a gym"/>
+          <p:cNvPr id="2" name="Image 0" descr="Man doing a dumbbell curl in a gym">    </p:cNvPr>
           <p:cNvPicPr>
             <a:picLocks noChangeAspect="1"/>
           </p:cNvPicPr>
           <p:nvPr/>
         </p:nvPicPr>
         <p:blipFill>
-          <a:blip r:embed="rId3"/>
-          <a:srcRect l="31099" r="25444"/>
+          <a:blip r:embed="rId1"/>
+          <a:srcRect l="31099" r="25444" t="0" b="0"/>
           <a:stretch/>
         </p:blipFill>
         <p:spPr>
@@ -1305,13 +1550,6 @@
           </a:gradFill>
           <a:ln/>
         </p:spPr>
-        <p:txBody>
-          <a:bodyPr/>
-          <a:lstStyle/>
-          <a:p>
-            <a:endParaRPr lang="en-US"/>
-          </a:p>
-        </p:txBody>
       </p:sp>
       <p:sp>
         <p:nvSpPr>
@@ -1332,13 +1570,6 @@
           </a:solidFill>
           <a:ln/>
         </p:spPr>
-        <p:txBody>
-          <a:bodyPr/>
-          <a:lstStyle/>
-          <a:p>
-            <a:endParaRPr lang="en-US"/>
-          </a:p>
-        </p:txBody>
       </p:sp>
       <p:sp>
         <p:nvSpPr>
@@ -1363,14 +1594,14 @@
           </a:bodyPr>
           <a:lstStyle/>
           <a:p>
-            <a:pPr marL="0" indent="0" algn="l">
+            <a:pPr algn="l" indent="0" marL="0">
               <a:lnSpc>
                 <a:spcPts val="1820"/>
               </a:lnSpc>
               <a:buNone/>
             </a:pPr>
             <a:r>
-              <a:rPr lang="en-US" sz="1300" b="1" kern="0" spc="200" dirty="0">
+              <a:rPr lang="en-US" sz="1300" b="1" spc="200" kern="0" dirty="0">
                 <a:solidFill>
                   <a:srgbClr val="FF6B35"/>
                 </a:solidFill>
@@ -1407,7 +1638,7 @@
           </a:bodyPr>
           <a:lstStyle/>
           <a:p>
-            <a:pPr marL="0" indent="0" algn="l">
+            <a:pPr algn="l" indent="0" marL="0">
               <a:lnSpc>
                 <a:spcPts val="6300"/>
               </a:lnSpc>
@@ -1459,7 +1690,7 @@
           </a:bodyPr>
           <a:lstStyle/>
           <a:p>
-            <a:pPr marL="0" indent="0" algn="l">
+            <a:pPr algn="l" indent="0" marL="0">
               <a:lnSpc>
                 <a:spcPts val="3080"/>
               </a:lnSpc>
@@ -1503,14 +1734,14 @@
           </a:bodyPr>
           <a:lstStyle/>
           <a:p>
-            <a:pPr marL="0" indent="0" algn="l">
+            <a:pPr algn="l" indent="0" marL="0">
               <a:lnSpc>
                 <a:spcPts val="1820"/>
               </a:lnSpc>
               <a:buNone/>
             </a:pPr>
             <a:r>
-              <a:rPr lang="en-US" sz="1300" b="1" kern="0" spc="200" dirty="0">
+              <a:rPr lang="en-US" sz="1300" b="1" spc="200" kern="0" dirty="0">
                 <a:solidFill>
                   <a:srgbClr val="FBE3D3"/>
                 </a:solidFill>
@@ -1547,7 +1778,7 @@
           </a:bodyPr>
           <a:lstStyle/>
           <a:p>
-            <a:pPr marL="0" indent="0" algn="l">
+            <a:pPr algn="l" indent="0" marL="0">
               <a:lnSpc>
                 <a:spcPts val="2240"/>
               </a:lnSpc>
@@ -1584,7 +1815,6 @@
         <a:solidFill>
           <a:srgbClr val="14181F"/>
         </a:solidFill>
-        <a:effectLst/>
       </p:bgPr>
     </p:bg>
     <p:spTree>
@@ -1603,15 +1833,15 @@
       </p:grpSpPr>
       <p:pic>
         <p:nvPicPr>
-          <p:cNvPr id="2" name="Image 0" descr="preencoded.png"/>
+          <p:cNvPr id="2" name="Image 0" descr="preencoded.png">    </p:cNvPr>
           <p:cNvPicPr>
             <a:picLocks noChangeAspect="1"/>
           </p:cNvPicPr>
           <p:nvPr/>
         </p:nvPicPr>
         <p:blipFill>
-          <a:blip r:embed="rId3"/>
-          <a:srcRect l="9722" r="9722"/>
+          <a:blip r:embed="rId1"/>
+          <a:srcRect l="9722" r="9722" t="0" b="0"/>
           <a:stretch/>
         </p:blipFill>
         <p:spPr>
@@ -1660,13 +1890,6 @@
           </a:gradFill>
           <a:ln/>
         </p:spPr>
-        <p:txBody>
-          <a:bodyPr/>
-          <a:lstStyle/>
-          <a:p>
-            <a:endParaRPr lang="en-US"/>
-          </a:p>
-        </p:txBody>
       </p:sp>
       <p:sp>
         <p:nvSpPr>
@@ -1691,14 +1914,14 @@
           </a:bodyPr>
           <a:lstStyle/>
           <a:p>
-            <a:pPr marL="0" indent="0" algn="l">
+            <a:pPr algn="l" indent="0" marL="0">
               <a:lnSpc>
                 <a:spcPts val="1820"/>
               </a:lnSpc>
               <a:buNone/>
             </a:pPr>
             <a:r>
-              <a:rPr lang="en-US" sz="1300" b="1" kern="0" spc="200" dirty="0">
+              <a:rPr lang="en-US" sz="1300" b="1" spc="200" kern="0" dirty="0">
                 <a:solidFill>
                   <a:srgbClr val="FF6B35"/>
                 </a:solidFill>
@@ -1735,7 +1958,7 @@
           </a:bodyPr>
           <a:lstStyle/>
           <a:p>
-            <a:pPr marL="0" indent="0" algn="l">
+            <a:pPr algn="l" indent="0" marL="0">
               <a:lnSpc>
                 <a:spcPts val="4140"/>
               </a:lnSpc>
@@ -1785,13 +2008,6 @@
           </a:solidFill>
           <a:ln/>
         </p:spPr>
-        <p:txBody>
-          <a:bodyPr/>
-          <a:lstStyle/>
-          <a:p>
-            <a:endParaRPr lang="en-US"/>
-          </a:p>
-        </p:txBody>
       </p:sp>
       <p:sp>
         <p:nvSpPr>
@@ -1816,7 +2032,7 @@
           </a:bodyPr>
           <a:lstStyle/>
           <a:p>
-            <a:pPr marL="0" indent="0" algn="l">
+            <a:pPr algn="l" indent="0" marL="0">
               <a:lnSpc>
                 <a:spcPts val="2860"/>
               </a:lnSpc>
@@ -1860,7 +2076,7 @@
           </a:bodyPr>
           <a:lstStyle/>
           <a:p>
-            <a:pPr marL="0" indent="0" algn="l">
+            <a:pPr algn="l" indent="0" marL="0">
               <a:lnSpc>
                 <a:spcPts val="2320"/>
               </a:lnSpc>
@@ -1897,7 +2113,6 @@
         <a:solidFill>
           <a:srgbClr val="14181F"/>
         </a:solidFill>
-        <a:effectLst/>
       </p:bgPr>
     </p:bg>
     <p:spTree>
@@ -1916,15 +2131,15 @@
       </p:grpSpPr>
       <p:pic>
         <p:nvPicPr>
-          <p:cNvPr id="2" name="Image 0" descr="preencoded.png"/>
+          <p:cNvPr id="2" name="Image 0" descr="preencoded.png">    </p:cNvPr>
           <p:cNvPicPr>
             <a:picLocks noChangeAspect="1"/>
           </p:cNvPicPr>
           <p:nvPr/>
         </p:nvPicPr>
         <p:blipFill>
-          <a:blip r:embed="rId3"/>
-          <a:srcRect t="12500" b="12500"/>
+          <a:blip r:embed="rId1"/>
+          <a:srcRect l="0" r="0" t="12500" b="12500"/>
           <a:stretch/>
         </p:blipFill>
         <p:spPr>
@@ -1973,13 +2188,6 @@
           </a:gradFill>
           <a:ln/>
         </p:spPr>
-        <p:txBody>
-          <a:bodyPr/>
-          <a:lstStyle/>
-          <a:p>
-            <a:endParaRPr lang="en-US"/>
-          </a:p>
-        </p:txBody>
       </p:sp>
       <p:sp>
         <p:nvSpPr>
@@ -2004,14 +2212,14 @@
           </a:bodyPr>
           <a:lstStyle/>
           <a:p>
-            <a:pPr marL="0" indent="0" algn="l">
+            <a:pPr algn="l" indent="0" marL="0">
               <a:lnSpc>
                 <a:spcPts val="1820"/>
               </a:lnSpc>
               <a:buNone/>
             </a:pPr>
             <a:r>
-              <a:rPr lang="en-US" sz="1300" b="1" kern="0" spc="200" dirty="0">
+              <a:rPr lang="en-US" sz="1300" b="1" spc="200" kern="0" dirty="0">
                 <a:solidFill>
                   <a:srgbClr val="FF6B35"/>
                 </a:solidFill>
@@ -2048,7 +2256,7 @@
           </a:bodyPr>
           <a:lstStyle/>
           <a:p>
-            <a:pPr marL="0" indent="0" algn="l">
+            <a:pPr algn="l" indent="0" marL="0">
               <a:lnSpc>
                 <a:spcPts val="4140"/>
               </a:lnSpc>
@@ -2100,13 +2308,6 @@
           </a:solidFill>
           <a:ln/>
         </p:spPr>
-        <p:txBody>
-          <a:bodyPr/>
-          <a:lstStyle/>
-          <a:p>
-            <a:endParaRPr lang="en-US"/>
-          </a:p>
-        </p:txBody>
       </p:sp>
       <p:sp>
         <p:nvSpPr>
@@ -2133,19 +2334,19 @@
                 <a:lnTo>
                   <a:pt x="0" y="101600"/>
                 </a:lnTo>
-                <a:arcTo wR="101600" hR="101600" stAng="10800000" swAng="5400000"/>
+                <a:arcTo hR="101600" wR="101600" stAng="10800000" swAng="5400000"/>
                 <a:lnTo>
                   <a:pt x="2387600" y="0"/>
                 </a:lnTo>
-                <a:arcTo wR="101600" hR="101600" stAng="16200000" swAng="5400000"/>
+                <a:arcTo hR="101600" wR="101600" stAng="16200000" swAng="5400000"/>
                 <a:lnTo>
                   <a:pt x="2489200" y="101600"/>
                 </a:lnTo>
-                <a:arcTo wR="101600" hR="63500" stAng="0" swAng="-5400000"/>
+                <a:arcTo hR="63500" wR="101600" stAng="0" swAng="-5400000"/>
                 <a:lnTo>
                   <a:pt x="101600" y="38100"/>
                 </a:lnTo>
-                <a:arcTo wR="101600" hR="63500" stAng="16200000" swAng="-5400000"/>
+                <a:arcTo hR="63500" wR="101600" stAng="16200000" swAng="-5400000"/>
                 <a:close/>
               </a:path>
             </a:pathLst>
@@ -2155,13 +2356,6 @@
           </a:solidFill>
           <a:ln/>
         </p:spPr>
-        <p:txBody>
-          <a:bodyPr/>
-          <a:lstStyle/>
-          <a:p>
-            <a:endParaRPr lang="en-US"/>
-          </a:p>
-        </p:txBody>
       </p:sp>
       <p:sp>
         <p:nvSpPr>
@@ -2186,7 +2380,7 @@
           </a:bodyPr>
           <a:lstStyle/>
           <a:p>
-            <a:pPr marL="0" indent="0" algn="l">
+            <a:pPr algn="l" indent="0" marL="0">
               <a:lnSpc>
                 <a:spcPts val="6000"/>
               </a:lnSpc>
@@ -2230,7 +2424,7 @@
           </a:bodyPr>
           <a:lstStyle/>
           <a:p>
-            <a:pPr marL="0" indent="0" algn="l">
+            <a:pPr algn="l" indent="0" marL="0">
               <a:lnSpc>
                 <a:spcPts val="2240"/>
               </a:lnSpc>
@@ -2274,7 +2468,7 @@
           </a:bodyPr>
           <a:lstStyle/>
           <a:p>
-            <a:pPr marL="0" indent="0" algn="l">
+            <a:pPr algn="l" indent="0" marL="0">
               <a:lnSpc>
                 <a:spcPts val="1820"/>
               </a:lnSpc>
@@ -2318,13 +2512,6 @@
           </a:solidFill>
           <a:ln/>
         </p:spPr>
-        <p:txBody>
-          <a:bodyPr/>
-          <a:lstStyle/>
-          <a:p>
-            <a:endParaRPr lang="en-US"/>
-          </a:p>
-        </p:txBody>
       </p:sp>
       <p:sp>
         <p:nvSpPr>
@@ -2351,19 +2538,19 @@
                 <a:lnTo>
                   <a:pt x="0" y="101600"/>
                 </a:lnTo>
-                <a:arcTo wR="101600" hR="101600" stAng="10800000" swAng="5400000"/>
+                <a:arcTo hR="101600" wR="101600" stAng="10800000" swAng="5400000"/>
                 <a:lnTo>
                   <a:pt x="2387600" y="0"/>
                 </a:lnTo>
-                <a:arcTo wR="101600" hR="101600" stAng="16200000" swAng="5400000"/>
+                <a:arcTo hR="101600" wR="101600" stAng="16200000" swAng="5400000"/>
                 <a:lnTo>
                   <a:pt x="2489200" y="101600"/>
                 </a:lnTo>
-                <a:arcTo wR="101600" hR="63500" stAng="0" swAng="-5400000"/>
+                <a:arcTo hR="63500" wR="101600" stAng="0" swAng="-5400000"/>
                 <a:lnTo>
                   <a:pt x="101600" y="38100"/>
                 </a:lnTo>
-                <a:arcTo wR="101600" hR="63500" stAng="16200000" swAng="-5400000"/>
+                <a:arcTo hR="63500" wR="101600" stAng="16200000" swAng="-5400000"/>
                 <a:close/>
               </a:path>
             </a:pathLst>
@@ -2373,13 +2560,6 @@
           </a:solidFill>
           <a:ln/>
         </p:spPr>
-        <p:txBody>
-          <a:bodyPr/>
-          <a:lstStyle/>
-          <a:p>
-            <a:endParaRPr lang="en-US"/>
-          </a:p>
-        </p:txBody>
       </p:sp>
       <p:sp>
         <p:nvSpPr>
@@ -2404,7 +2584,7 @@
           </a:bodyPr>
           <a:lstStyle/>
           <a:p>
-            <a:pPr marL="0" indent="0" algn="l">
+            <a:pPr algn="l" indent="0" marL="0">
               <a:lnSpc>
                 <a:spcPts val="6000"/>
               </a:lnSpc>
@@ -2448,7 +2628,7 @@
           </a:bodyPr>
           <a:lstStyle/>
           <a:p>
-            <a:pPr marL="0" indent="0" algn="l">
+            <a:pPr algn="l" indent="0" marL="0">
               <a:lnSpc>
                 <a:spcPts val="2240"/>
               </a:lnSpc>
@@ -2492,7 +2672,7 @@
           </a:bodyPr>
           <a:lstStyle/>
           <a:p>
-            <a:pPr marL="0" indent="0" algn="l">
+            <a:pPr algn="l" indent="0" marL="0">
               <a:lnSpc>
                 <a:spcPts val="1820"/>
               </a:lnSpc>
@@ -2536,13 +2716,6 @@
           </a:solidFill>
           <a:ln/>
         </p:spPr>
-        <p:txBody>
-          <a:bodyPr/>
-          <a:lstStyle/>
-          <a:p>
-            <a:endParaRPr lang="en-US"/>
-          </a:p>
-        </p:txBody>
       </p:sp>
       <p:sp>
         <p:nvSpPr>
@@ -2569,19 +2742,19 @@
                 <a:lnTo>
                   <a:pt x="0" y="101600"/>
                 </a:lnTo>
-                <a:arcTo wR="101600" hR="101600" stAng="10800000" swAng="5400000"/>
+                <a:arcTo hR="101600" wR="101600" stAng="10800000" swAng="5400000"/>
                 <a:lnTo>
                   <a:pt x="2387600" y="0"/>
                 </a:lnTo>
-                <a:arcTo wR="101600" hR="101600" stAng="16200000" swAng="5400000"/>
+                <a:arcTo hR="101600" wR="101600" stAng="16200000" swAng="5400000"/>
                 <a:lnTo>
                   <a:pt x="2489200" y="101600"/>
                 </a:lnTo>
-                <a:arcTo wR="101600" hR="63500" stAng="0" swAng="-5400000"/>
+                <a:arcTo hR="63500" wR="101600" stAng="0" swAng="-5400000"/>
                 <a:lnTo>
                   <a:pt x="101600" y="38100"/>
                 </a:lnTo>
-                <a:arcTo wR="101600" hR="63500" stAng="16200000" swAng="-5400000"/>
+                <a:arcTo hR="63500" wR="101600" stAng="16200000" swAng="-5400000"/>
                 <a:close/>
               </a:path>
             </a:pathLst>
@@ -2591,13 +2764,6 @@
           </a:solidFill>
           <a:ln/>
         </p:spPr>
-        <p:txBody>
-          <a:bodyPr/>
-          <a:lstStyle/>
-          <a:p>
-            <a:endParaRPr lang="en-US"/>
-          </a:p>
-        </p:txBody>
       </p:sp>
       <p:sp>
         <p:nvSpPr>
@@ -2622,7 +2788,7 @@
           </a:bodyPr>
           <a:lstStyle/>
           <a:p>
-            <a:pPr marL="0" indent="0" algn="l">
+            <a:pPr algn="l" indent="0" marL="0">
               <a:lnSpc>
                 <a:spcPts val="6000"/>
               </a:lnSpc>
@@ -2666,7 +2832,7 @@
           </a:bodyPr>
           <a:lstStyle/>
           <a:p>
-            <a:pPr marL="0" indent="0" algn="l">
+            <a:pPr algn="l" indent="0" marL="0">
               <a:lnSpc>
                 <a:spcPts val="2240"/>
               </a:lnSpc>
@@ -2710,7 +2876,7 @@
           </a:bodyPr>
           <a:lstStyle/>
           <a:p>
-            <a:pPr marL="0" indent="0" algn="l">
+            <a:pPr algn="l" indent="0" marL="0">
               <a:lnSpc>
                 <a:spcPts val="1820"/>
               </a:lnSpc>
@@ -2754,13 +2920,6 @@
           </a:solidFill>
           <a:ln/>
         </p:spPr>
-        <p:txBody>
-          <a:bodyPr/>
-          <a:lstStyle/>
-          <a:p>
-            <a:endParaRPr lang="en-US"/>
-          </a:p>
-        </p:txBody>
       </p:sp>
       <p:sp>
         <p:nvSpPr>
@@ -2787,19 +2946,19 @@
                 <a:lnTo>
                   <a:pt x="0" y="101600"/>
                 </a:lnTo>
-                <a:arcTo wR="101600" hR="101600" stAng="10800000" swAng="5400000"/>
+                <a:arcTo hR="101600" wR="101600" stAng="10800000" swAng="5400000"/>
                 <a:lnTo>
                   <a:pt x="2387600" y="0"/>
                 </a:lnTo>
-                <a:arcTo wR="101600" hR="101600" stAng="16200000" swAng="5400000"/>
+                <a:arcTo hR="101600" wR="101600" stAng="16200000" swAng="5400000"/>
                 <a:lnTo>
                   <a:pt x="2489200" y="101600"/>
                 </a:lnTo>
-                <a:arcTo wR="101600" hR="63500" stAng="0" swAng="-5400000"/>
+                <a:arcTo hR="63500" wR="101600" stAng="0" swAng="-5400000"/>
                 <a:lnTo>
                   <a:pt x="101600" y="38100"/>
                 </a:lnTo>
-                <a:arcTo wR="101600" hR="63500" stAng="16200000" swAng="-5400000"/>
+                <a:arcTo hR="63500" wR="101600" stAng="16200000" swAng="-5400000"/>
                 <a:close/>
               </a:path>
             </a:pathLst>
@@ -2809,13 +2968,6 @@
           </a:solidFill>
           <a:ln/>
         </p:spPr>
-        <p:txBody>
-          <a:bodyPr/>
-          <a:lstStyle/>
-          <a:p>
-            <a:endParaRPr lang="en-US"/>
-          </a:p>
-        </p:txBody>
       </p:sp>
       <p:sp>
         <p:nvSpPr>
@@ -2840,7 +2992,7 @@
           </a:bodyPr>
           <a:lstStyle/>
           <a:p>
-            <a:pPr marL="0" indent="0" algn="l">
+            <a:pPr algn="l" indent="0" marL="0">
               <a:lnSpc>
                 <a:spcPts val="6000"/>
               </a:lnSpc>
@@ -2884,7 +3036,7 @@
           </a:bodyPr>
           <a:lstStyle/>
           <a:p>
-            <a:pPr marL="0" indent="0" algn="l">
+            <a:pPr algn="l" indent="0" marL="0">
               <a:lnSpc>
                 <a:spcPts val="2240"/>
               </a:lnSpc>
@@ -2928,7 +3080,7 @@
           </a:bodyPr>
           <a:lstStyle/>
           <a:p>
-            <a:pPr marL="0" indent="0" algn="l">
+            <a:pPr algn="l" indent="0" marL="0">
               <a:lnSpc>
                 <a:spcPts val="1820"/>
               </a:lnSpc>
@@ -2972,7 +3124,7 @@
           </a:bodyPr>
           <a:lstStyle/>
           <a:p>
-            <a:pPr marL="0" indent="0" algn="l">
+            <a:pPr algn="l" indent="0" marL="0">
               <a:lnSpc>
                 <a:spcPts val="1820"/>
               </a:lnSpc>
@@ -3009,7 +3161,6 @@
         <a:solidFill>
           <a:srgbClr val="14181F"/>
         </a:solidFill>
-        <a:effectLst/>
       </p:bgPr>
     </p:bg>
     <p:spTree>
@@ -3028,15 +3179,15 @@
       </p:grpSpPr>
       <p:pic>
         <p:nvPicPr>
-          <p:cNvPr id="2" name="Image 0" descr="preencoded.png"/>
+          <p:cNvPr id="2" name="Image 0" descr="preencoded.png">    </p:cNvPr>
           <p:cNvPicPr>
             <a:picLocks noChangeAspect="1"/>
           </p:cNvPicPr>
           <p:nvPr/>
         </p:nvPicPr>
         <p:blipFill>
-          <a:blip r:embed="rId3"/>
-          <a:srcRect t="11604" b="11604"/>
+          <a:blip r:embed="rId1"/>
+          <a:srcRect l="0" r="0" t="11604" b="11604"/>
           <a:stretch/>
         </p:blipFill>
         <p:spPr>
@@ -3085,13 +3236,6 @@
           </a:gradFill>
           <a:ln/>
         </p:spPr>
-        <p:txBody>
-          <a:bodyPr/>
-          <a:lstStyle/>
-          <a:p>
-            <a:endParaRPr lang="en-US"/>
-          </a:p>
-        </p:txBody>
       </p:sp>
       <p:sp>
         <p:nvSpPr>
@@ -3116,14 +3260,14 @@
           </a:bodyPr>
           <a:lstStyle/>
           <a:p>
-            <a:pPr marL="0" indent="0" algn="l">
+            <a:pPr algn="l" indent="0" marL="0">
               <a:lnSpc>
                 <a:spcPts val="1820"/>
               </a:lnSpc>
               <a:buNone/>
             </a:pPr>
             <a:r>
-              <a:rPr lang="en-US" sz="1300" b="1" kern="0" spc="200" dirty="0">
+              <a:rPr lang="en-US" sz="1300" b="1" spc="200" kern="0" dirty="0">
                 <a:solidFill>
                   <a:srgbClr val="FF6B35"/>
                 </a:solidFill>
@@ -3160,7 +3304,7 @@
           </a:bodyPr>
           <a:lstStyle/>
           <a:p>
-            <a:pPr marL="0" indent="0" algn="l">
+            <a:pPr algn="l" indent="0" marL="0">
               <a:lnSpc>
                 <a:spcPts val="4140"/>
               </a:lnSpc>
@@ -3183,7 +3327,7 @@
                 <a:ea typeface="Oswald" pitchFamily="34" charset="-122"/>
                 <a:cs typeface="Oswald" pitchFamily="34" charset="-120"/>
               </a:rPr>
-              <a:t>Three questions we want to answer</a:t>
+              <a:t>Four questions we want to answer</a:t>
             </a:r>
             <a:endParaRPr lang="en-US" sz="3600" dirty="0"/>
           </a:p>
@@ -3198,11 +3342,11 @@
         <p:spPr>
           <a:xfrm>
             <a:off x="812800" y="2077690"/>
-            <a:ext cx="3386634" cy="2682081"/>
+            <a:ext cx="2489200" cy="3639542"/>
           </a:xfrm>
           <a:prstGeom prst="roundRect">
             <a:avLst>
-              <a:gd name="adj" fmla="val 3788"/>
+              <a:gd name="adj" fmla="val 4082"/>
             </a:avLst>
           </a:prstGeom>
           <a:solidFill>
@@ -3212,13 +3356,6 @@
           </a:solidFill>
           <a:ln/>
         </p:spPr>
-        <p:txBody>
-          <a:bodyPr/>
-          <a:lstStyle/>
-          <a:p>
-            <a:endParaRPr lang="en-US"/>
-          </a:p>
-        </p:txBody>
       </p:sp>
       <p:sp>
         <p:nvSpPr>
@@ -3229,7 +3366,7 @@
         <p:spPr>
           <a:xfrm>
             <a:off x="812800" y="2077690"/>
-            <a:ext cx="3386634" cy="2682081"/>
+            <a:ext cx="2489200" cy="3639542"/>
           </a:xfrm>
           <a:custGeom>
             <a:avLst/>
@@ -3238,26 +3375,26 @@
             <a:cxnLst/>
             <a:rect l="l" t="t" r="r" b="b"/>
             <a:pathLst>
-              <a:path w="3386634" h="2682081">
+              <a:path w="2489200" h="3639542">
                 <a:moveTo>
                   <a:pt x="0" y="101600"/>
                 </a:moveTo>
                 <a:lnTo>
                   <a:pt x="0" y="101600"/>
                 </a:lnTo>
-                <a:arcTo wR="101600" hR="101600" stAng="10800000" swAng="5400000"/>
+                <a:arcTo hR="101600" wR="101600" stAng="10800000" swAng="5400000"/>
                 <a:lnTo>
-                  <a:pt x="3285034" y="0"/>
+                  <a:pt x="2387600" y="0"/>
                 </a:lnTo>
-                <a:arcTo wR="101600" hR="101600" stAng="16200000" swAng="5400000"/>
+                <a:arcTo hR="101600" wR="101600" stAng="16200000" swAng="5400000"/>
                 <a:lnTo>
-                  <a:pt x="3386634" y="101600"/>
+                  <a:pt x="2489200" y="101600"/>
                 </a:lnTo>
-                <a:arcTo wR="101600" hR="63500" stAng="0" swAng="-5400000"/>
+                <a:arcTo hR="63500" wR="101600" stAng="0" swAng="-5400000"/>
                 <a:lnTo>
                   <a:pt x="101600" y="38100"/>
                 </a:lnTo>
-                <a:arcTo wR="101600" hR="63500" stAng="16200000" swAng="-5400000"/>
+                <a:arcTo hR="63500" wR="101600" stAng="16200000" swAng="-5400000"/>
                 <a:close/>
               </a:path>
             </a:pathLst>
@@ -3267,13 +3404,6 @@
           </a:solidFill>
           <a:ln/>
         </p:spPr>
-        <p:txBody>
-          <a:bodyPr/>
-          <a:lstStyle/>
-          <a:p>
-            <a:endParaRPr lang="en-US"/>
-          </a:p>
-        </p:txBody>
       </p:sp>
       <p:sp>
         <p:nvSpPr>
@@ -3284,28 +3414,28 @@
         <p:spPr>
           <a:xfrm>
             <a:off x="1066800" y="2369790"/>
-            <a:ext cx="2964993" cy="238720"/>
-          </a:xfrm>
-          <a:prstGeom prst="rect">
-            <a:avLst/>
-          </a:prstGeom>
-          <a:noFill/>
-          <a:ln/>
-        </p:spPr>
-        <p:txBody>
-          <a:bodyPr wrap="square" lIns="0" tIns="0" rIns="0" bIns="0" rtlCol="0" anchor="t">
-            <a:normAutofit/>
-          </a:bodyPr>
-          <a:lstStyle/>
-          <a:p>
-            <a:pPr marL="0" indent="0" algn="l">
+            <a:ext cx="2040636" cy="238720"/>
+          </a:xfrm>
+          <a:prstGeom prst="rect">
+            <a:avLst/>
+          </a:prstGeom>
+          <a:noFill/>
+          <a:ln/>
+        </p:spPr>
+        <p:txBody>
+          <a:bodyPr wrap="square" lIns="0" tIns="0" rIns="0" bIns="0" rtlCol="0" anchor="t">
+            <a:normAutofit/>
+          </a:bodyPr>
+          <a:lstStyle/>
+          <a:p>
+            <a:pPr algn="l" indent="0" marL="0">
               <a:lnSpc>
                 <a:spcPts val="1680"/>
               </a:lnSpc>
               <a:buNone/>
             </a:pPr>
             <a:r>
-              <a:rPr lang="en-US" sz="1200" b="1" kern="0" spc="150" dirty="0">
+              <a:rPr lang="en-US" sz="1200" b="1" spc="150" kern="0" dirty="0">
                 <a:solidFill>
                   <a:srgbClr val="FF6B35"/>
                 </a:solidFill>
@@ -3313,7 +3443,7 @@
                 <a:ea typeface="DM Sans" pitchFamily="34" charset="-122"/>
                 <a:cs typeface="DM Sans" pitchFamily="34" charset="-120"/>
               </a:rPr>
-              <a:t>CLASSIFICATION</a:t>
+              <a:t>REGRESSION</a:t>
             </a:r>
             <a:endParaRPr lang="en-US" sz="1200" dirty="0"/>
           </a:p>
@@ -3328,21 +3458,21 @@
         <p:spPr>
           <a:xfrm>
             <a:off x="1066800" y="2684711"/>
-            <a:ext cx="2964993" cy="533400"/>
-          </a:xfrm>
-          <a:prstGeom prst="rect">
-            <a:avLst/>
-          </a:prstGeom>
-          <a:noFill/>
-          <a:ln/>
-        </p:spPr>
-        <p:txBody>
-          <a:bodyPr wrap="square" lIns="0" tIns="0" rIns="0" bIns="0" rtlCol="0" anchor="t">
-            <a:normAutofit/>
-          </a:bodyPr>
-          <a:lstStyle/>
-          <a:p>
-            <a:pPr marL="0" indent="0" algn="l">
+            <a:ext cx="2040636" cy="787400"/>
+          </a:xfrm>
+          <a:prstGeom prst="rect">
+            <a:avLst/>
+          </a:prstGeom>
+          <a:noFill/>
+          <a:ln/>
+        </p:spPr>
+        <p:txBody>
+          <a:bodyPr wrap="square" lIns="0" tIns="0" rIns="0" bIns="0" rtlCol="0" anchor="t">
+            <a:normAutofit/>
+          </a:bodyPr>
+          <a:lstStyle/>
+          <a:p>
+            <a:pPr algn="l" indent="0" marL="0">
               <a:lnSpc>
                 <a:spcPts val="2000"/>
               </a:lnSpc>
@@ -3357,7 +3487,7 @@
                 <a:ea typeface="DM Sans" pitchFamily="34" charset="-122"/>
                 <a:cs typeface="DM Sans" pitchFamily="34" charset="-120"/>
               </a:rPr>
-              <a:t>Will a workout burn a little, a lot, or in between?</a:t>
+              <a:t>Which factors matter most, and how much?</a:t>
             </a:r>
             <a:endParaRPr lang="en-US" sz="1600" dirty="0"/>
           </a:p>
@@ -3371,22 +3501,22 @@
         </p:nvSpPr>
         <p:spPr>
           <a:xfrm>
-            <a:off x="1066800" y="3294311"/>
-            <a:ext cx="2964993" cy="982861"/>
-          </a:xfrm>
-          <a:prstGeom prst="rect">
-            <a:avLst/>
-          </a:prstGeom>
-          <a:noFill/>
-          <a:ln/>
-        </p:spPr>
-        <p:txBody>
-          <a:bodyPr wrap="square" lIns="0" tIns="0" rIns="0" bIns="0" rtlCol="0" anchor="t">
-            <a:normAutofit/>
-          </a:bodyPr>
-          <a:lstStyle/>
-          <a:p>
-            <a:pPr marL="0" indent="0" algn="l">
+            <a:off x="1066800" y="3548311"/>
+            <a:ext cx="2040636" cy="1940322"/>
+          </a:xfrm>
+          <a:prstGeom prst="rect">
+            <a:avLst/>
+          </a:prstGeom>
+          <a:noFill/>
+          <a:ln/>
+        </p:spPr>
+        <p:txBody>
+          <a:bodyPr wrap="square" lIns="0" tIns="0" rIns="0" bIns="0" rtlCol="0" anchor="t">
+            <a:normAutofit/>
+          </a:bodyPr>
+          <a:lstStyle/>
+          <a:p>
+            <a:pPr algn="l" indent="0" marL="0">
               <a:lnSpc>
                 <a:spcPts val="1885"/>
               </a:lnSpc>
@@ -3401,7 +3531,7 @@
                 <a:ea typeface="DM Sans" pitchFamily="34" charset="-122"/>
                 <a:cs typeface="DM Sans" pitchFamily="34" charset="-120"/>
               </a:rPr>
-              <a:t>We’ll sort workouts into Low (under 500 kcal), Medium (500–900) or High (over 900) and predict which group a session lands in.</a:t>
+              <a:t>We’ll build one regression model that predicts calories burned and shows how much each factor, like session length, experience and body fat, pushes the number up or down.</a:t>
             </a:r>
             <a:endParaRPr lang="en-US" sz="1300" dirty="0"/>
           </a:p>
@@ -3415,12 +3545,12 @@
         </p:nvSpPr>
         <p:spPr>
           <a:xfrm>
-            <a:off x="4402634" y="2077690"/>
-            <a:ext cx="3386683" cy="2682081"/>
+            <a:off x="3505200" y="2077690"/>
+            <a:ext cx="2489200" cy="3639542"/>
           </a:xfrm>
           <a:prstGeom prst="roundRect">
             <a:avLst>
-              <a:gd name="adj" fmla="val 3788"/>
+              <a:gd name="adj" fmla="val 4082"/>
             </a:avLst>
           </a:prstGeom>
           <a:solidFill>
@@ -3430,13 +3560,6 @@
           </a:solidFill>
           <a:ln/>
         </p:spPr>
-        <p:txBody>
-          <a:bodyPr/>
-          <a:lstStyle/>
-          <a:p>
-            <a:endParaRPr lang="en-US"/>
-          </a:p>
-        </p:txBody>
       </p:sp>
       <p:sp>
         <p:nvSpPr>
@@ -3446,8 +3569,8 @@
         </p:nvSpPr>
         <p:spPr>
           <a:xfrm>
-            <a:off x="4402634" y="2077690"/>
-            <a:ext cx="3386683" cy="2682081"/>
+            <a:off x="3505200" y="2077690"/>
+            <a:ext cx="2489200" cy="3639542"/>
           </a:xfrm>
           <a:custGeom>
             <a:avLst/>
@@ -3456,26 +3579,26 @@
             <a:cxnLst/>
             <a:rect l="l" t="t" r="r" b="b"/>
             <a:pathLst>
-              <a:path w="3386683" h="2682081">
+              <a:path w="2489200" h="3639542">
                 <a:moveTo>
                   <a:pt x="0" y="101600"/>
                 </a:moveTo>
                 <a:lnTo>
                   <a:pt x="0" y="101600"/>
                 </a:lnTo>
-                <a:arcTo wR="101600" hR="101600" stAng="10800000" swAng="5400000"/>
+                <a:arcTo hR="101600" wR="101600" stAng="10800000" swAng="5400000"/>
                 <a:lnTo>
-                  <a:pt x="3285083" y="0"/>
+                  <a:pt x="2387600" y="0"/>
                 </a:lnTo>
-                <a:arcTo wR="101600" hR="101600" stAng="16200000" swAng="5400000"/>
+                <a:arcTo hR="101600" wR="101600" stAng="16200000" swAng="5400000"/>
                 <a:lnTo>
-                  <a:pt x="3386683" y="101600"/>
+                  <a:pt x="2489200" y="101600"/>
                 </a:lnTo>
-                <a:arcTo wR="101600" hR="63500" stAng="0" swAng="-5400000"/>
+                <a:arcTo hR="63500" wR="101600" stAng="0" swAng="-5400000"/>
                 <a:lnTo>
                   <a:pt x="101600" y="38100"/>
                 </a:lnTo>
-                <a:arcTo wR="101600" hR="63500" stAng="16200000" swAng="-5400000"/>
+                <a:arcTo hR="63500" wR="101600" stAng="16200000" swAng="-5400000"/>
                 <a:close/>
               </a:path>
             </a:pathLst>
@@ -3485,13 +3608,6 @@
           </a:solidFill>
           <a:ln/>
         </p:spPr>
-        <p:txBody>
-          <a:bodyPr/>
-          <a:lstStyle/>
-          <a:p>
-            <a:endParaRPr lang="en-US"/>
-          </a:p>
-        </p:txBody>
       </p:sp>
       <p:sp>
         <p:nvSpPr>
@@ -3501,29 +3617,29 @@
         </p:nvSpPr>
         <p:spPr>
           <a:xfrm>
-            <a:off x="4656634" y="2369790"/>
-            <a:ext cx="2965044" cy="238720"/>
-          </a:xfrm>
-          <a:prstGeom prst="rect">
-            <a:avLst/>
-          </a:prstGeom>
-          <a:noFill/>
-          <a:ln/>
-        </p:spPr>
-        <p:txBody>
-          <a:bodyPr wrap="square" lIns="0" tIns="0" rIns="0" bIns="0" rtlCol="0" anchor="t">
-            <a:normAutofit/>
-          </a:bodyPr>
-          <a:lstStyle/>
-          <a:p>
-            <a:pPr marL="0" indent="0" algn="l">
+            <a:off x="3759200" y="2369790"/>
+            <a:ext cx="2040636" cy="238720"/>
+          </a:xfrm>
+          <a:prstGeom prst="rect">
+            <a:avLst/>
+          </a:prstGeom>
+          <a:noFill/>
+          <a:ln/>
+        </p:spPr>
+        <p:txBody>
+          <a:bodyPr wrap="square" lIns="0" tIns="0" rIns="0" bIns="0" rtlCol="0" anchor="t">
+            <a:normAutofit/>
+          </a:bodyPr>
+          <a:lstStyle/>
+          <a:p>
+            <a:pPr algn="l" indent="0" marL="0">
               <a:lnSpc>
                 <a:spcPts val="1680"/>
               </a:lnSpc>
               <a:buNone/>
             </a:pPr>
             <a:r>
-              <a:rPr lang="en-US" sz="1200" b="1" kern="0" spc="150" dirty="0">
+              <a:rPr lang="en-US" sz="1200" b="1" spc="150" kern="0" dirty="0">
                 <a:solidFill>
                   <a:srgbClr val="FF6B35"/>
                 </a:solidFill>
@@ -3531,7 +3647,7 @@
                 <a:ea typeface="DM Sans" pitchFamily="34" charset="-122"/>
                 <a:cs typeface="DM Sans" pitchFamily="34" charset="-120"/>
               </a:rPr>
-              <a:t>ASSOCIATION RULES</a:t>
+              <a:t>CLASSIFICATION</a:t>
             </a:r>
             <a:endParaRPr lang="en-US" sz="1200" dirty="0"/>
           </a:p>
@@ -3545,22 +3661,22 @@
         </p:nvSpPr>
         <p:spPr>
           <a:xfrm>
-            <a:off x="4656634" y="2684711"/>
-            <a:ext cx="2965044" cy="787400"/>
-          </a:xfrm>
-          <a:prstGeom prst="rect">
-            <a:avLst/>
-          </a:prstGeom>
-          <a:noFill/>
-          <a:ln/>
-        </p:spPr>
-        <p:txBody>
-          <a:bodyPr wrap="square" lIns="0" tIns="0" rIns="0" bIns="0" rtlCol="0" anchor="t">
-            <a:normAutofit/>
-          </a:bodyPr>
-          <a:lstStyle/>
-          <a:p>
-            <a:pPr marL="0" indent="0" algn="l">
+            <a:off x="3759200" y="2684711"/>
+            <a:ext cx="2040636" cy="787400"/>
+          </a:xfrm>
+          <a:prstGeom prst="rect">
+            <a:avLst/>
+          </a:prstGeom>
+          <a:noFill/>
+          <a:ln/>
+        </p:spPr>
+        <p:txBody>
+          <a:bodyPr wrap="square" lIns="0" tIns="0" rIns="0" bIns="0" rtlCol="0" anchor="t">
+            <a:normAutofit/>
+          </a:bodyPr>
+          <a:lstStyle/>
+          <a:p>
+            <a:pPr algn="l" indent="0" marL="0">
               <a:lnSpc>
                 <a:spcPts val="2000"/>
               </a:lnSpc>
@@ -3575,7 +3691,7 @@
                 <a:ea typeface="DM Sans" pitchFamily="34" charset="-122"/>
                 <a:cs typeface="DM Sans" pitchFamily="34" charset="-120"/>
               </a:rPr>
-              <a:t>Which habits show up together in big-burn workouts?</a:t>
+              <a:t>Will a workout burn a little, a lot, or in between?</a:t>
             </a:r>
             <a:endParaRPr lang="en-US" sz="1600" dirty="0"/>
           </a:p>
@@ -3589,22 +3705,22 @@
         </p:nvSpPr>
         <p:spPr>
           <a:xfrm>
-            <a:off x="4656634" y="3548311"/>
-            <a:ext cx="2965044" cy="982861"/>
-          </a:xfrm>
-          <a:prstGeom prst="rect">
-            <a:avLst/>
-          </a:prstGeom>
-          <a:noFill/>
-          <a:ln/>
-        </p:spPr>
-        <p:txBody>
-          <a:bodyPr wrap="square" lIns="0" tIns="0" rIns="0" bIns="0" rtlCol="0" anchor="t">
-            <a:normAutofit/>
-          </a:bodyPr>
-          <a:lstStyle/>
-          <a:p>
-            <a:pPr marL="0" indent="0" algn="l">
+            <a:off x="3759200" y="3548311"/>
+            <a:ext cx="2040636" cy="1461591"/>
+          </a:xfrm>
+          <a:prstGeom prst="rect">
+            <a:avLst/>
+          </a:prstGeom>
+          <a:noFill/>
+          <a:ln/>
+        </p:spPr>
+        <p:txBody>
+          <a:bodyPr wrap="square" lIns="0" tIns="0" rIns="0" bIns="0" rtlCol="0" anchor="t">
+            <a:normAutofit/>
+          </a:bodyPr>
+          <a:lstStyle/>
+          <a:p>
+            <a:pPr algn="l" indent="0" marL="0">
               <a:lnSpc>
                 <a:spcPts val="1885"/>
               </a:lnSpc>
@@ -3619,7 +3735,7 @@
                 <a:ea typeface="DM Sans" pitchFamily="34" charset="-122"/>
                 <a:cs typeface="DM Sans" pitchFamily="34" charset="-120"/>
               </a:rPr>
-              <a:t>We’ll look for patterns like long session + expert + low body fat → high calories. Simple “if this, then that” rules anyone can read.</a:t>
+              <a:t>We’ll sort workouts into Low (under 500 kcal), Medium (500–900) or High (over 900) and predict which group a session lands in.</a:t>
             </a:r>
             <a:endParaRPr lang="en-US" sz="1300" dirty="0"/>
           </a:p>
@@ -3633,12 +3749,12 @@
         </p:nvSpPr>
         <p:spPr>
           <a:xfrm>
-            <a:off x="7992517" y="2077690"/>
-            <a:ext cx="3386683" cy="2682081"/>
+            <a:off x="6197600" y="2077690"/>
+            <a:ext cx="2489200" cy="3639542"/>
           </a:xfrm>
           <a:prstGeom prst="roundRect">
             <a:avLst>
-              <a:gd name="adj" fmla="val 3788"/>
+              <a:gd name="adj" fmla="val 4082"/>
             </a:avLst>
           </a:prstGeom>
           <a:solidFill>
@@ -3648,13 +3764,6 @@
           </a:solidFill>
           <a:ln/>
         </p:spPr>
-        <p:txBody>
-          <a:bodyPr/>
-          <a:lstStyle/>
-          <a:p>
-            <a:endParaRPr lang="en-US"/>
-          </a:p>
-        </p:txBody>
       </p:sp>
       <p:sp>
         <p:nvSpPr>
@@ -3664,8 +3773,8 @@
         </p:nvSpPr>
         <p:spPr>
           <a:xfrm>
-            <a:off x="7992517" y="2077690"/>
-            <a:ext cx="3386683" cy="2682081"/>
+            <a:off x="6197600" y="2077690"/>
+            <a:ext cx="2489200" cy="3639542"/>
           </a:xfrm>
           <a:custGeom>
             <a:avLst/>
@@ -3674,26 +3783,26 @@
             <a:cxnLst/>
             <a:rect l="l" t="t" r="r" b="b"/>
             <a:pathLst>
-              <a:path w="3386683" h="2682081">
+              <a:path w="2489200" h="3639542">
                 <a:moveTo>
                   <a:pt x="0" y="101600"/>
                 </a:moveTo>
                 <a:lnTo>
                   <a:pt x="0" y="101600"/>
                 </a:lnTo>
-                <a:arcTo wR="101600" hR="101600" stAng="10800000" swAng="5400000"/>
+                <a:arcTo hR="101600" wR="101600" stAng="10800000" swAng="5400000"/>
                 <a:lnTo>
-                  <a:pt x="3285083" y="0"/>
+                  <a:pt x="2387600" y="0"/>
                 </a:lnTo>
-                <a:arcTo wR="101600" hR="101600" stAng="16200000" swAng="5400000"/>
+                <a:arcTo hR="101600" wR="101600" stAng="16200000" swAng="5400000"/>
                 <a:lnTo>
-                  <a:pt x="3386683" y="101600"/>
+                  <a:pt x="2489200" y="101600"/>
                 </a:lnTo>
-                <a:arcTo wR="101600" hR="63500" stAng="0" swAng="-5400000"/>
+                <a:arcTo hR="63500" wR="101600" stAng="0" swAng="-5400000"/>
                 <a:lnTo>
                   <a:pt x="101600" y="38100"/>
                 </a:lnTo>
-                <a:arcTo wR="101600" hR="63500" stAng="16200000" swAng="-5400000"/>
+                <a:arcTo hR="63500" wR="101600" stAng="16200000" swAng="-5400000"/>
                 <a:close/>
               </a:path>
             </a:pathLst>
@@ -3703,13 +3812,6 @@
           </a:solidFill>
           <a:ln/>
         </p:spPr>
-        <p:txBody>
-          <a:bodyPr/>
-          <a:lstStyle/>
-          <a:p>
-            <a:endParaRPr lang="en-US"/>
-          </a:p>
-        </p:txBody>
       </p:sp>
       <p:sp>
         <p:nvSpPr>
@@ -3719,29 +3821,29 @@
         </p:nvSpPr>
         <p:spPr>
           <a:xfrm>
-            <a:off x="8246517" y="2369790"/>
-            <a:ext cx="2965044" cy="238720"/>
-          </a:xfrm>
-          <a:prstGeom prst="rect">
-            <a:avLst/>
-          </a:prstGeom>
-          <a:noFill/>
-          <a:ln/>
-        </p:spPr>
-        <p:txBody>
-          <a:bodyPr wrap="square" lIns="0" tIns="0" rIns="0" bIns="0" rtlCol="0" anchor="t">
-            <a:normAutofit/>
-          </a:bodyPr>
-          <a:lstStyle/>
-          <a:p>
-            <a:pPr marL="0" indent="0" algn="l">
+            <a:off x="6451600" y="2369790"/>
+            <a:ext cx="2040636" cy="238720"/>
+          </a:xfrm>
+          <a:prstGeom prst="rect">
+            <a:avLst/>
+          </a:prstGeom>
+          <a:noFill/>
+          <a:ln/>
+        </p:spPr>
+        <p:txBody>
+          <a:bodyPr wrap="square" lIns="0" tIns="0" rIns="0" bIns="0" rtlCol="0" anchor="t">
+            <a:normAutofit/>
+          </a:bodyPr>
+          <a:lstStyle/>
+          <a:p>
+            <a:pPr algn="l" indent="0" marL="0">
               <a:lnSpc>
                 <a:spcPts val="1680"/>
               </a:lnSpc>
               <a:buNone/>
             </a:pPr>
             <a:r>
-              <a:rPr lang="en-US" sz="1200" b="1" kern="0" spc="150" dirty="0">
+              <a:rPr lang="en-US" sz="1200" b="1" spc="150" kern="0" dirty="0">
                 <a:solidFill>
                   <a:srgbClr val="FF6B35"/>
                 </a:solidFill>
@@ -3749,7 +3851,7 @@
                 <a:ea typeface="DM Sans" pitchFamily="34" charset="-122"/>
                 <a:cs typeface="DM Sans" pitchFamily="34" charset="-120"/>
               </a:rPr>
-              <a:t>CLUSTERING</a:t>
+              <a:t>ASSOCIATION RULES</a:t>
             </a:r>
             <a:endParaRPr lang="en-US" sz="1200" dirty="0"/>
           </a:p>
@@ -3763,22 +3865,22 @@
         </p:nvSpPr>
         <p:spPr>
           <a:xfrm>
-            <a:off x="8246517" y="2684711"/>
-            <a:ext cx="2965044" cy="533400"/>
-          </a:xfrm>
-          <a:prstGeom prst="rect">
-            <a:avLst/>
-          </a:prstGeom>
-          <a:noFill/>
-          <a:ln/>
-        </p:spPr>
-        <p:txBody>
-          <a:bodyPr wrap="square" lIns="0" tIns="0" rIns="0" bIns="0" rtlCol="0" anchor="t">
-            <a:normAutofit/>
-          </a:bodyPr>
-          <a:lstStyle/>
-          <a:p>
-            <a:pPr marL="0" indent="0" algn="l">
+            <a:off x="6451600" y="2684711"/>
+            <a:ext cx="2040636" cy="787400"/>
+          </a:xfrm>
+          <a:prstGeom prst="rect">
+            <a:avLst/>
+          </a:prstGeom>
+          <a:noFill/>
+          <a:ln/>
+        </p:spPr>
+        <p:txBody>
+          <a:bodyPr wrap="square" lIns="0" tIns="0" rIns="0" bIns="0" rtlCol="0" anchor="t">
+            <a:normAutofit/>
+          </a:bodyPr>
+          <a:lstStyle/>
+          <a:p>
+            <a:pPr algn="l" indent="0" marL="0">
               <a:lnSpc>
                 <a:spcPts val="2000"/>
               </a:lnSpc>
@@ -3793,6 +3895,210 @@
                 <a:ea typeface="DM Sans" pitchFamily="34" charset="-122"/>
                 <a:cs typeface="DM Sans" pitchFamily="34" charset="-120"/>
               </a:rPr>
+              <a:t>Which habits show up together in big-burn workouts?</a:t>
+            </a:r>
+            <a:endParaRPr lang="en-US" sz="1600" dirty="0"/>
+          </a:p>
+        </p:txBody>
+      </p:sp>
+      <p:sp>
+        <p:nvSpPr>
+          <p:cNvPr id="20" name="Text 17"/>
+          <p:cNvSpPr/>
+          <p:nvPr/>
+        </p:nvSpPr>
+        <p:spPr>
+          <a:xfrm>
+            <a:off x="6451600" y="3548311"/>
+            <a:ext cx="2040636" cy="1461591"/>
+          </a:xfrm>
+          <a:prstGeom prst="rect">
+            <a:avLst/>
+          </a:prstGeom>
+          <a:noFill/>
+          <a:ln/>
+        </p:spPr>
+        <p:txBody>
+          <a:bodyPr wrap="square" lIns="0" tIns="0" rIns="0" bIns="0" rtlCol="0" anchor="t">
+            <a:normAutofit/>
+          </a:bodyPr>
+          <a:lstStyle/>
+          <a:p>
+            <a:pPr algn="l" indent="0" marL="0">
+              <a:lnSpc>
+                <a:spcPts val="1885"/>
+              </a:lnSpc>
+              <a:buNone/>
+            </a:pPr>
+            <a:r>
+              <a:rPr lang="en-US" sz="1300" dirty="0">
+                <a:solidFill>
+                  <a:srgbClr val="FBE3D3"/>
+                </a:solidFill>
+                <a:latin typeface="DM Sans" pitchFamily="34" charset="0"/>
+                <a:ea typeface="DM Sans" pitchFamily="34" charset="-122"/>
+                <a:cs typeface="DM Sans" pitchFamily="34" charset="-120"/>
+              </a:rPr>
+              <a:t>We’ll look for patterns like long session + expert + low body fat → high calories. Simple “if this, then that” rules anyone can read.</a:t>
+            </a:r>
+            <a:endParaRPr lang="en-US" sz="1300" dirty="0"/>
+          </a:p>
+        </p:txBody>
+      </p:sp>
+      <p:sp>
+        <p:nvSpPr>
+          <p:cNvPr id="21" name="Shape 18"/>
+          <p:cNvSpPr/>
+          <p:nvPr/>
+        </p:nvSpPr>
+        <p:spPr>
+          <a:xfrm>
+            <a:off x="8890000" y="2077690"/>
+            <a:ext cx="2489200" cy="3639542"/>
+          </a:xfrm>
+          <a:prstGeom prst="roundRect">
+            <a:avLst>
+              <a:gd name="adj" fmla="val 4082"/>
+            </a:avLst>
+          </a:prstGeom>
+          <a:solidFill>
+            <a:srgbClr val="1E242D">
+              <a:alpha val="80000"/>
+            </a:srgbClr>
+          </a:solidFill>
+          <a:ln/>
+        </p:spPr>
+      </p:sp>
+      <p:sp>
+        <p:nvSpPr>
+          <p:cNvPr id="22" name="Shape 19"/>
+          <p:cNvSpPr/>
+          <p:nvPr/>
+        </p:nvSpPr>
+        <p:spPr>
+          <a:xfrm>
+            <a:off x="8890000" y="2077690"/>
+            <a:ext cx="2489200" cy="3639542"/>
+          </a:xfrm>
+          <a:custGeom>
+            <a:avLst/>
+            <a:gdLst/>
+            <a:ahLst/>
+            <a:cxnLst/>
+            <a:rect l="l" t="t" r="r" b="b"/>
+            <a:pathLst>
+              <a:path w="2489200" h="3639542">
+                <a:moveTo>
+                  <a:pt x="0" y="101600"/>
+                </a:moveTo>
+                <a:lnTo>
+                  <a:pt x="0" y="101600"/>
+                </a:lnTo>
+                <a:arcTo hR="101600" wR="101600" stAng="10800000" swAng="5400000"/>
+                <a:lnTo>
+                  <a:pt x="2387600" y="0"/>
+                </a:lnTo>
+                <a:arcTo hR="101600" wR="101600" stAng="16200000" swAng="5400000"/>
+                <a:lnTo>
+                  <a:pt x="2489200" y="101600"/>
+                </a:lnTo>
+                <a:arcTo hR="63500" wR="101600" stAng="0" swAng="-5400000"/>
+                <a:lnTo>
+                  <a:pt x="101600" y="38100"/>
+                </a:lnTo>
+                <a:arcTo hR="63500" wR="101600" stAng="16200000" swAng="-5400000"/>
+                <a:close/>
+              </a:path>
+            </a:pathLst>
+          </a:custGeom>
+          <a:solidFill>
+            <a:srgbClr val="FF6B35"/>
+          </a:solidFill>
+          <a:ln/>
+        </p:spPr>
+      </p:sp>
+      <p:sp>
+        <p:nvSpPr>
+          <p:cNvPr id="23" name="Text 20"/>
+          <p:cNvSpPr/>
+          <p:nvPr/>
+        </p:nvSpPr>
+        <p:spPr>
+          <a:xfrm>
+            <a:off x="9144000" y="2369790"/>
+            <a:ext cx="2040636" cy="238720"/>
+          </a:xfrm>
+          <a:prstGeom prst="rect">
+            <a:avLst/>
+          </a:prstGeom>
+          <a:noFill/>
+          <a:ln/>
+        </p:spPr>
+        <p:txBody>
+          <a:bodyPr wrap="square" lIns="0" tIns="0" rIns="0" bIns="0" rtlCol="0" anchor="t">
+            <a:normAutofit/>
+          </a:bodyPr>
+          <a:lstStyle/>
+          <a:p>
+            <a:pPr algn="l" indent="0" marL="0">
+              <a:lnSpc>
+                <a:spcPts val="1680"/>
+              </a:lnSpc>
+              <a:buNone/>
+            </a:pPr>
+            <a:r>
+              <a:rPr lang="en-US" sz="1200" b="1" spc="150" kern="0" dirty="0">
+                <a:solidFill>
+                  <a:srgbClr val="FF6B35"/>
+                </a:solidFill>
+                <a:latin typeface="DM Sans" pitchFamily="34" charset="0"/>
+                <a:ea typeface="DM Sans" pitchFamily="34" charset="-122"/>
+                <a:cs typeface="DM Sans" pitchFamily="34" charset="-120"/>
+              </a:rPr>
+              <a:t>CLUSTERING</a:t>
+            </a:r>
+            <a:endParaRPr lang="en-US" sz="1200" dirty="0"/>
+          </a:p>
+        </p:txBody>
+      </p:sp>
+      <p:sp>
+        <p:nvSpPr>
+          <p:cNvPr id="24" name="Text 21"/>
+          <p:cNvSpPr/>
+          <p:nvPr/>
+        </p:nvSpPr>
+        <p:spPr>
+          <a:xfrm>
+            <a:off x="9144000" y="2684711"/>
+            <a:ext cx="2040636" cy="787400"/>
+          </a:xfrm>
+          <a:prstGeom prst="rect">
+            <a:avLst/>
+          </a:prstGeom>
+          <a:noFill/>
+          <a:ln/>
+        </p:spPr>
+        <p:txBody>
+          <a:bodyPr wrap="square" lIns="0" tIns="0" rIns="0" bIns="0" rtlCol="0" anchor="t">
+            <a:normAutofit/>
+          </a:bodyPr>
+          <a:lstStyle/>
+          <a:p>
+            <a:pPr algn="l" indent="0" marL="0">
+              <a:lnSpc>
+                <a:spcPts val="2000"/>
+              </a:lnSpc>
+              <a:buNone/>
+            </a:pPr>
+            <a:r>
+              <a:rPr lang="en-US" sz="1600" b="1" dirty="0">
+                <a:solidFill>
+                  <a:srgbClr val="FFC857"/>
+                </a:solidFill>
+                <a:latin typeface="DM Sans" pitchFamily="34" charset="0"/>
+                <a:ea typeface="DM Sans" pitchFamily="34" charset="-122"/>
+                <a:cs typeface="DM Sans" pitchFamily="34" charset="-120"/>
+              </a:rPr>
               <a:t>What kinds of workouts naturally group together?</a:t>
             </a:r>
             <a:endParaRPr lang="en-US" sz="1600" dirty="0"/>
@@ -3801,28 +4107,28 @@
       </p:sp>
       <p:sp>
         <p:nvSpPr>
-          <p:cNvPr id="20" name="Text 17"/>
-          <p:cNvSpPr/>
-          <p:nvPr/>
-        </p:nvSpPr>
-        <p:spPr>
-          <a:xfrm>
-            <a:off x="8246517" y="3294311"/>
-            <a:ext cx="2965044" cy="982861"/>
-          </a:xfrm>
-          <a:prstGeom prst="rect">
-            <a:avLst/>
-          </a:prstGeom>
-          <a:noFill/>
-          <a:ln/>
-        </p:spPr>
-        <p:txBody>
-          <a:bodyPr wrap="square" lIns="0" tIns="0" rIns="0" bIns="0" rtlCol="0" anchor="t">
-            <a:normAutofit/>
-          </a:bodyPr>
-          <a:lstStyle/>
-          <a:p>
-            <a:pPr marL="0" indent="0" algn="l">
+          <p:cNvPr id="25" name="Text 22"/>
+          <p:cNvSpPr/>
+          <p:nvPr/>
+        </p:nvSpPr>
+        <p:spPr>
+          <a:xfrm>
+            <a:off x="9144000" y="3548311"/>
+            <a:ext cx="2040636" cy="1222226"/>
+          </a:xfrm>
+          <a:prstGeom prst="rect">
+            <a:avLst/>
+          </a:prstGeom>
+          <a:noFill/>
+          <a:ln/>
+        </p:spPr>
+        <p:txBody>
+          <a:bodyPr wrap="square" lIns="0" tIns="0" rIns="0" bIns="0" rtlCol="0" anchor="t">
+            <a:normAutofit/>
+          </a:bodyPr>
+          <a:lstStyle/>
+          <a:p>
+            <a:pPr algn="l" indent="0" marL="0">
               <a:lnSpc>
                 <a:spcPts val="1885"/>
               </a:lnSpc>
@@ -3859,7 +4165,6 @@
         <a:solidFill>
           <a:srgbClr val="14181F"/>
         </a:solidFill>
-        <a:effectLst/>
       </p:bgPr>
     </p:bg>
     <p:spTree>
@@ -3878,15 +4183,15 @@
       </p:grpSpPr>
       <p:pic>
         <p:nvPicPr>
-          <p:cNvPr id="2" name="Image 0" descr="preencoded.png"/>
+          <p:cNvPr id="2" name="Image 0" descr="preencoded.png">    </p:cNvPr>
           <p:cNvPicPr>
             <a:picLocks noChangeAspect="1"/>
           </p:cNvPicPr>
           <p:nvPr/>
         </p:nvPicPr>
         <p:blipFill>
-          <a:blip r:embed="rId3"/>
-          <a:srcRect t="21799" b="21799"/>
+          <a:blip r:embed="rId1"/>
+          <a:srcRect l="0" r="0" t="21799" b="21799"/>
           <a:stretch/>
         </p:blipFill>
         <p:spPr>
@@ -3935,13 +4240,6 @@
           </a:gradFill>
           <a:ln/>
         </p:spPr>
-        <p:txBody>
-          <a:bodyPr/>
-          <a:lstStyle/>
-          <a:p>
-            <a:endParaRPr lang="en-US"/>
-          </a:p>
-        </p:txBody>
       </p:sp>
       <p:sp>
         <p:nvSpPr>
@@ -3966,14 +4264,14 @@
           </a:bodyPr>
           <a:lstStyle/>
           <a:p>
-            <a:pPr marL="0" indent="0" algn="l">
+            <a:pPr algn="l" indent="0" marL="0">
               <a:lnSpc>
                 <a:spcPts val="1820"/>
               </a:lnSpc>
               <a:buNone/>
             </a:pPr>
             <a:r>
-              <a:rPr lang="en-US" sz="1300" b="1" kern="0" spc="200" dirty="0">
+              <a:rPr lang="en-US" sz="1300" b="1" spc="200" kern="0" dirty="0">
                 <a:solidFill>
                   <a:srgbClr val="FF6B35"/>
                 </a:solidFill>
@@ -4010,7 +4308,7 @@
           </a:bodyPr>
           <a:lstStyle/>
           <a:p>
-            <a:pPr marL="0" indent="0" algn="l">
+            <a:pPr algn="l" indent="0" marL="0">
               <a:lnSpc>
                 <a:spcPts val="4140"/>
               </a:lnSpc>
@@ -4062,7 +4360,7 @@
           </a:bodyPr>
           <a:lstStyle/>
           <a:p>
-            <a:pPr marL="0" indent="0" algn="l">
+            <a:pPr algn="l" indent="0" marL="0">
               <a:lnSpc>
                 <a:spcPts val="6000"/>
               </a:lnSpc>
@@ -4106,7 +4404,7 @@
           </a:bodyPr>
           <a:lstStyle/>
           <a:p>
-            <a:pPr marL="0" indent="0" algn="l">
+            <a:pPr algn="l" indent="0" marL="0">
               <a:lnSpc>
                 <a:spcPts val="1820"/>
               </a:lnSpc>
@@ -4150,7 +4448,7 @@
           </a:bodyPr>
           <a:lstStyle/>
           <a:p>
-            <a:pPr marL="0" indent="0" algn="l">
+            <a:pPr algn="l" indent="0" marL="0">
               <a:lnSpc>
                 <a:spcPts val="6000"/>
               </a:lnSpc>
@@ -4194,7 +4492,7 @@
           </a:bodyPr>
           <a:lstStyle/>
           <a:p>
-            <a:pPr marL="0" indent="0" algn="l">
+            <a:pPr algn="l" indent="0" marL="0">
               <a:lnSpc>
                 <a:spcPts val="1820"/>
               </a:lnSpc>
@@ -4238,7 +4536,7 @@
           </a:bodyPr>
           <a:lstStyle/>
           <a:p>
-            <a:pPr marL="0" indent="0" algn="l">
+            <a:pPr algn="l" indent="0" marL="0">
               <a:lnSpc>
                 <a:spcPts val="1820"/>
               </a:lnSpc>
@@ -4258,7 +4556,7 @@
             <a:endParaRPr lang="en-US" sz="1300" dirty="0"/>
           </a:p>
           <a:p>
-            <a:pPr marL="0" indent="0" algn="l">
+            <a:pPr algn="l" indent="0" marL="0">
               <a:lnSpc>
                 <a:spcPts val="1820"/>
               </a:lnSpc>
@@ -4272,7 +4570,7 @@
                 <a:latin typeface="DM Sans" pitchFamily="34" charset="0"/>
                 <a:ea typeface="DM Sans" pitchFamily="34" charset="-122"/>
                 <a:cs typeface="DM Sans" pitchFamily="34" charset="-120"/>
-                <a:hlinkClick r:id="rId4">
+                <a:hlinkClick r:id="rId2" invalidUrl="" action="" tgtFrame="" tooltip="" history="1" highlightClick="0" endSnd="0">
                   <a:extLst>
                     <a:ext uri="{A12FA001-AC4F-418D-AE19-62706E023703}">
                       <ahyp:hlinkClr xmlns:ahyp="http://schemas.microsoft.com/office/drawing/2018/hyperlinkcolor" val="tx"/>
@@ -4285,7 +4583,7 @@
             <a:endParaRPr lang="en-US" sz="1300" dirty="0"/>
           </a:p>
           <a:p>
-            <a:pPr marL="0" indent="0" algn="l">
+            <a:pPr algn="l" indent="0" marL="0">
               <a:lnSpc>
                 <a:spcPts val="1820"/>
               </a:lnSpc>
@@ -4299,7 +4597,7 @@
                 <a:latin typeface="DM Sans" pitchFamily="34" charset="0"/>
                 <a:ea typeface="DM Sans" pitchFamily="34" charset="-122"/>
                 <a:cs typeface="DM Sans" pitchFamily="34" charset="-120"/>
-                <a:hlinkClick r:id="rId4">
+                <a:hlinkClick r:id="rId3" invalidUrl="" action="" tgtFrame="" tooltip="" history="1" highlightClick="0" endSnd="0">
                   <a:extLst>
                     <a:ext uri="{A12FA001-AC4F-418D-AE19-62706E023703}">
                       <ahyp:hlinkClr xmlns:ahyp="http://schemas.microsoft.com/office/drawing/2018/hyperlinkcolor" val="tx"/>
@@ -4334,13 +4632,6 @@
           </a:solidFill>
           <a:ln/>
         </p:spPr>
-        <p:txBody>
-          <a:bodyPr/>
-          <a:lstStyle/>
-          <a:p>
-            <a:endParaRPr lang="en-US"/>
-          </a:p>
-        </p:txBody>
       </p:sp>
       <p:sp>
         <p:nvSpPr>
@@ -4365,7 +4656,7 @@
           </a:bodyPr>
           <a:lstStyle/>
           <a:p>
-            <a:pPr marL="0" indent="0" algn="l">
+            <a:pPr algn="l" indent="0" marL="0">
               <a:lnSpc>
                 <a:spcPts val="1920"/>
               </a:lnSpc>
@@ -4409,7 +4700,7 @@
           </a:bodyPr>
           <a:lstStyle/>
           <a:p>
-            <a:pPr marL="0" indent="0" algn="l">
+            <a:pPr algn="l" indent="0" marL="0">
               <a:lnSpc>
                 <a:spcPts val="1820"/>
               </a:lnSpc>
@@ -4451,13 +4742,6 @@
           </a:solidFill>
           <a:ln/>
         </p:spPr>
-        <p:txBody>
-          <a:bodyPr/>
-          <a:lstStyle/>
-          <a:p>
-            <a:endParaRPr lang="en-US"/>
-          </a:p>
-        </p:txBody>
       </p:sp>
       <p:sp>
         <p:nvSpPr>
@@ -4482,7 +4766,7 @@
           </a:bodyPr>
           <a:lstStyle/>
           <a:p>
-            <a:pPr marL="0" indent="0" algn="l">
+            <a:pPr algn="l" indent="0" marL="0">
               <a:lnSpc>
                 <a:spcPts val="1920"/>
               </a:lnSpc>
@@ -4526,7 +4810,7 @@
           </a:bodyPr>
           <a:lstStyle/>
           <a:p>
-            <a:pPr marL="0" indent="0" algn="l">
+            <a:pPr algn="l" indent="0" marL="0">
               <a:lnSpc>
                 <a:spcPts val="1820"/>
               </a:lnSpc>
@@ -4568,13 +4852,6 @@
           </a:solidFill>
           <a:ln/>
         </p:spPr>
-        <p:txBody>
-          <a:bodyPr/>
-          <a:lstStyle/>
-          <a:p>
-            <a:endParaRPr lang="en-US"/>
-          </a:p>
-        </p:txBody>
       </p:sp>
       <p:sp>
         <p:nvSpPr>
@@ -4599,7 +4876,7 @@
           </a:bodyPr>
           <a:lstStyle/>
           <a:p>
-            <a:pPr marL="0" indent="0" algn="l">
+            <a:pPr algn="l" indent="0" marL="0">
               <a:lnSpc>
                 <a:spcPts val="1920"/>
               </a:lnSpc>
@@ -4643,7 +4920,7 @@
           </a:bodyPr>
           <a:lstStyle/>
           <a:p>
-            <a:pPr marL="0" indent="0" algn="l">
+            <a:pPr algn="l" indent="0" marL="0">
               <a:lnSpc>
                 <a:spcPts val="1820"/>
               </a:lnSpc>
@@ -4685,13 +4962,6 @@
           </a:solidFill>
           <a:ln/>
         </p:spPr>
-        <p:txBody>
-          <a:bodyPr/>
-          <a:lstStyle/>
-          <a:p>
-            <a:endParaRPr lang="en-US"/>
-          </a:p>
-        </p:txBody>
       </p:sp>
       <p:sp>
         <p:nvSpPr>
@@ -4716,7 +4986,7 @@
           </a:bodyPr>
           <a:lstStyle/>
           <a:p>
-            <a:pPr marL="0" indent="0" algn="l">
+            <a:pPr algn="l" indent="0" marL="0">
               <a:lnSpc>
                 <a:spcPts val="1920"/>
               </a:lnSpc>
@@ -4760,7 +5030,7 @@
           </a:bodyPr>
           <a:lstStyle/>
           <a:p>
-            <a:pPr marL="0" indent="0" algn="l">
+            <a:pPr algn="l" indent="0" marL="0">
               <a:lnSpc>
                 <a:spcPts val="1820"/>
               </a:lnSpc>
@@ -4797,7 +5067,6 @@
         <a:solidFill>
           <a:srgbClr val="14181F"/>
         </a:solidFill>
-        <a:effectLst/>
       </p:bgPr>
     </p:bg>
     <p:spTree>
@@ -4837,14 +5106,14 @@
           </a:bodyPr>
           <a:lstStyle/>
           <a:p>
-            <a:pPr marL="0" indent="0" algn="l">
+            <a:pPr algn="l" indent="0" marL="0">
               <a:lnSpc>
                 <a:spcPts val="1820"/>
               </a:lnSpc>
               <a:buNone/>
             </a:pPr>
             <a:r>
-              <a:rPr lang="en-US" sz="1300" b="1" kern="0" spc="200" dirty="0">
+              <a:rPr lang="en-US" sz="1300" b="1" spc="200" kern="0" dirty="0">
                 <a:solidFill>
                   <a:srgbClr val="FF6B35"/>
                 </a:solidFill>
@@ -4881,7 +5150,7 @@
           </a:bodyPr>
           <a:lstStyle/>
           <a:p>
-            <a:pPr marL="0" indent="0" algn="l">
+            <a:pPr algn="l" indent="0" marL="0">
               <a:lnSpc>
                 <a:spcPts val="4140"/>
               </a:lnSpc>
@@ -4931,13 +5200,6 @@
           </a:solidFill>
           <a:ln/>
         </p:spPr>
-        <p:txBody>
-          <a:bodyPr/>
-          <a:lstStyle/>
-          <a:p>
-            <a:endParaRPr lang="en-US"/>
-          </a:p>
-        </p:txBody>
       </p:sp>
       <p:sp>
         <p:nvSpPr>
@@ -4964,19 +5226,19 @@
                 <a:lnTo>
                   <a:pt x="0" y="101600"/>
                 </a:lnTo>
-                <a:arcTo wR="101600" hR="101600" stAng="10800000" swAng="5400000"/>
+                <a:arcTo hR="101600" wR="101600" stAng="10800000" swAng="5400000"/>
                 <a:lnTo>
                   <a:pt x="5080000" y="0"/>
                 </a:lnTo>
-                <a:arcTo wR="101600" hR="101600" stAng="16200000" swAng="5400000"/>
+                <a:arcTo hR="101600" wR="101600" stAng="16200000" swAng="5400000"/>
                 <a:lnTo>
                   <a:pt x="5181600" y="101600"/>
                 </a:lnTo>
-                <a:arcTo wR="101600" hR="63500" stAng="0" swAng="-5400000"/>
+                <a:arcTo hR="63500" wR="101600" stAng="0" swAng="-5400000"/>
                 <a:lnTo>
                   <a:pt x="101600" y="38100"/>
                 </a:lnTo>
-                <a:arcTo wR="101600" hR="63500" stAng="16200000" swAng="-5400000"/>
+                <a:arcTo hR="63500" wR="101600" stAng="16200000" swAng="-5400000"/>
                 <a:close/>
               </a:path>
             </a:pathLst>
@@ -4986,13 +5248,6 @@
           </a:solidFill>
           <a:ln/>
         </p:spPr>
-        <p:txBody>
-          <a:bodyPr/>
-          <a:lstStyle/>
-          <a:p>
-            <a:endParaRPr lang="en-US"/>
-          </a:p>
-        </p:txBody>
       </p:sp>
       <p:sp>
         <p:nvSpPr>
@@ -5017,14 +5272,14 @@
           </a:bodyPr>
           <a:lstStyle/>
           <a:p>
-            <a:pPr marL="0" indent="0" algn="l">
+            <a:pPr algn="l" indent="0" marL="0">
               <a:lnSpc>
                 <a:spcPts val="1680"/>
               </a:lnSpc>
               <a:buNone/>
             </a:pPr>
             <a:r>
-              <a:rPr lang="en-US" sz="1200" b="1" kern="0" spc="150" dirty="0">
+              <a:rPr lang="en-US" sz="1200" b="1" spc="150" kern="0" dirty="0">
                 <a:solidFill>
                   <a:srgbClr val="FF6B35"/>
                 </a:solidFill>
@@ -5061,7 +5316,7 @@
           </a:bodyPr>
           <a:lstStyle/>
           <a:p>
-            <a:pPr marL="0" indent="0" algn="l">
+            <a:pPr algn="l" indent="0" marL="0">
               <a:lnSpc>
                 <a:spcPts val="2000"/>
               </a:lnSpc>
@@ -5105,7 +5360,7 @@
           </a:bodyPr>
           <a:lstStyle/>
           <a:p>
-            <a:pPr marL="0" indent="0" algn="l">
+            <a:pPr algn="l" indent="0" marL="0">
               <a:lnSpc>
                 <a:spcPts val="1885"/>
               </a:lnSpc>
@@ -5149,7 +5404,7 @@
           </a:bodyPr>
           <a:lstStyle/>
           <a:p>
-            <a:pPr marL="0" indent="0" algn="l">
+            <a:pPr algn="l" indent="0" marL="0">
               <a:lnSpc>
                 <a:spcPts val="1680"/>
               </a:lnSpc>
@@ -5163,7 +5418,7 @@
                 <a:latin typeface="DM Sans" pitchFamily="34" charset="0"/>
                 <a:ea typeface="DM Sans" pitchFamily="34" charset="-122"/>
                 <a:cs typeface="DM Sans" pitchFamily="34" charset="-120"/>
-                <a:hlinkClick r:id="rId3">
+                <a:hlinkClick r:id="rId1" invalidUrl="" action="" tgtFrame="" tooltip="" history="1" highlightClick="0" endSnd="0">
                   <a:extLst>
                     <a:ext uri="{A12FA001-AC4F-418D-AE19-62706E023703}">
                       <ahyp:hlinkClr xmlns:ahyp="http://schemas.microsoft.com/office/drawing/2018/hyperlinkcolor" val="tx"/>
@@ -5176,7 +5431,7 @@
             <a:endParaRPr lang="en-US" sz="1200" dirty="0"/>
           </a:p>
           <a:p>
-            <a:pPr marL="0" indent="0" algn="l">
+            <a:pPr algn="l" indent="0" marL="0">
               <a:lnSpc>
                 <a:spcPts val="1680"/>
               </a:lnSpc>
@@ -5190,7 +5445,7 @@
                 <a:latin typeface="DM Sans" pitchFamily="34" charset="0"/>
                 <a:ea typeface="DM Sans" pitchFamily="34" charset="-122"/>
                 <a:cs typeface="DM Sans" pitchFamily="34" charset="-120"/>
-                <a:hlinkClick r:id="rId3">
+                <a:hlinkClick r:id="rId2" invalidUrl="" action="" tgtFrame="" tooltip="" history="1" highlightClick="0" endSnd="0">
                   <a:extLst>
                     <a:ext uri="{A12FA001-AC4F-418D-AE19-62706E023703}">
                       <ahyp:hlinkClr xmlns:ahyp="http://schemas.microsoft.com/office/drawing/2018/hyperlinkcolor" val="tx"/>
@@ -5225,13 +5480,6 @@
           </a:solidFill>
           <a:ln/>
         </p:spPr>
-        <p:txBody>
-          <a:bodyPr/>
-          <a:lstStyle/>
-          <a:p>
-            <a:endParaRPr lang="en-US"/>
-          </a:p>
-        </p:txBody>
       </p:sp>
       <p:sp>
         <p:nvSpPr>
@@ -5258,19 +5506,19 @@
                 <a:lnTo>
                   <a:pt x="0" y="101600"/>
                 </a:lnTo>
-                <a:arcTo wR="101600" hR="101600" stAng="10800000" swAng="5400000"/>
+                <a:arcTo hR="101600" wR="101600" stAng="10800000" swAng="5400000"/>
                 <a:lnTo>
                   <a:pt x="5080000" y="0"/>
                 </a:lnTo>
-                <a:arcTo wR="101600" hR="101600" stAng="16200000" swAng="5400000"/>
+                <a:arcTo hR="101600" wR="101600" stAng="16200000" swAng="5400000"/>
                 <a:lnTo>
                   <a:pt x="5181600" y="101600"/>
                 </a:lnTo>
-                <a:arcTo wR="101600" hR="63500" stAng="0" swAng="-5400000"/>
+                <a:arcTo hR="63500" wR="101600" stAng="0" swAng="-5400000"/>
                 <a:lnTo>
                   <a:pt x="101600" y="38100"/>
                 </a:lnTo>
-                <a:arcTo wR="101600" hR="63500" stAng="16200000" swAng="-5400000"/>
+                <a:arcTo hR="63500" wR="101600" stAng="16200000" swAng="-5400000"/>
                 <a:close/>
               </a:path>
             </a:pathLst>
@@ -5280,13 +5528,6 @@
           </a:solidFill>
           <a:ln/>
         </p:spPr>
-        <p:txBody>
-          <a:bodyPr/>
-          <a:lstStyle/>
-          <a:p>
-            <a:endParaRPr lang="en-US"/>
-          </a:p>
-        </p:txBody>
       </p:sp>
       <p:sp>
         <p:nvSpPr>
@@ -5311,14 +5552,14 @@
           </a:bodyPr>
           <a:lstStyle/>
           <a:p>
-            <a:pPr marL="0" indent="0" algn="l">
+            <a:pPr algn="l" indent="0" marL="0">
               <a:lnSpc>
                 <a:spcPts val="1680"/>
               </a:lnSpc>
               <a:buNone/>
             </a:pPr>
             <a:r>
-              <a:rPr lang="en-US" sz="1200" b="1" kern="0" spc="150" dirty="0">
+              <a:rPr lang="en-US" sz="1200" b="1" spc="150" kern="0" dirty="0">
                 <a:solidFill>
                   <a:srgbClr val="FF6B35"/>
                 </a:solidFill>
@@ -5355,7 +5596,7 @@
           </a:bodyPr>
           <a:lstStyle/>
           <a:p>
-            <a:pPr marL="213360" indent="-169418" algn="l">
+            <a:pPr algn="l" marL="213360" indent="-169418">
               <a:lnSpc>
                 <a:spcPts val="2030"/>
               </a:lnSpc>
@@ -5371,12 +5612,12 @@
                 <a:ea typeface="DM Sans" pitchFamily="34" charset="-122"/>
                 <a:cs typeface="DM Sans" pitchFamily="34" charset="-120"/>
               </a:rPr>
-              <a:t>Predict whether a workout burns a low, medium or high amount, not an exact number</a:t>
+              <a:t>Predict both the exact calories (regression) and a low, medium or high level (classification)</a:t>
             </a:r>
             <a:endParaRPr lang="en-US" sz="1400" dirty="0"/>
           </a:p>
           <a:p>
-            <a:pPr marL="213360" indent="-169418" algn="l">
+            <a:pPr algn="l" marL="213360" indent="-169418">
               <a:lnSpc>
                 <a:spcPts val="2030"/>
               </a:lnSpc>
@@ -5397,7 +5638,7 @@
             <a:endParaRPr lang="en-US" sz="1400" dirty="0"/>
           </a:p>
           <a:p>
-            <a:pPr marL="213360" indent="-169418" algn="l">
+            <a:pPr algn="l" marL="213360" indent="-169418">
               <a:lnSpc>
                 <a:spcPts val="2030"/>
               </a:lnSpc>
@@ -5435,7 +5676,6 @@
         <a:solidFill>
           <a:srgbClr val="14181F"/>
         </a:solidFill>
-        <a:effectLst/>
       </p:bgPr>
     </p:bg>
     <p:spTree>
@@ -5454,15 +5694,15 @@
       </p:grpSpPr>
       <p:pic>
         <p:nvPicPr>
-          <p:cNvPr id="2" name="Image 0" descr="preencoded.png"/>
+          <p:cNvPr id="2" name="Image 0" descr="preencoded.png">    </p:cNvPr>
           <p:cNvPicPr>
             <a:picLocks noChangeAspect="1"/>
           </p:cNvPicPr>
           <p:nvPr/>
         </p:nvPicPr>
         <p:blipFill>
-          <a:blip r:embed="rId3"/>
-          <a:srcRect t="7780" b="7780"/>
+          <a:blip r:embed="rId1"/>
+          <a:srcRect l="0" r="0" t="7780" b="7780"/>
           <a:stretch/>
         </p:blipFill>
         <p:spPr>
@@ -5511,13 +5751,6 @@
           </a:gradFill>
           <a:ln/>
         </p:spPr>
-        <p:txBody>
-          <a:bodyPr/>
-          <a:lstStyle/>
-          <a:p>
-            <a:endParaRPr lang="en-US"/>
-          </a:p>
-        </p:txBody>
       </p:sp>
       <p:sp>
         <p:nvSpPr>
@@ -5542,14 +5775,14 @@
           </a:bodyPr>
           <a:lstStyle/>
           <a:p>
-            <a:pPr marL="0" indent="0" algn="l">
+            <a:pPr algn="l" indent="0" marL="0">
               <a:lnSpc>
                 <a:spcPts val="1820"/>
               </a:lnSpc>
               <a:buNone/>
             </a:pPr>
             <a:r>
-              <a:rPr lang="en-US" sz="1300" b="1" kern="0" spc="200" dirty="0">
+              <a:rPr lang="en-US" sz="1300" b="1" spc="200" kern="0" dirty="0">
                 <a:solidFill>
                   <a:srgbClr val="FF6B35"/>
                 </a:solidFill>
@@ -5586,7 +5819,7 @@
           </a:bodyPr>
           <a:lstStyle/>
           <a:p>
-            <a:pPr marL="0" indent="0" algn="l">
+            <a:pPr algn="l" indent="0" marL="0">
               <a:lnSpc>
                 <a:spcPts val="4140"/>
               </a:lnSpc>
@@ -5637,13 +5870,6 @@
             <a:prstDash val="solid"/>
           </a:ln>
         </p:spPr>
-        <p:txBody>
-          <a:bodyPr/>
-          <a:lstStyle/>
-          <a:p>
-            <a:endParaRPr lang="en-US"/>
-          </a:p>
-        </p:txBody>
       </p:sp>
       <p:sp>
         <p:nvSpPr>
@@ -5668,7 +5894,7 @@
           </a:bodyPr>
           <a:lstStyle/>
           <a:p>
-            <a:pPr marL="0" indent="0" algn="l">
+            <a:pPr algn="l" indent="0" marL="0">
               <a:lnSpc>
                 <a:spcPts val="2000"/>
               </a:lnSpc>
@@ -5712,7 +5938,7 @@
           </a:bodyPr>
           <a:lstStyle/>
           <a:p>
-            <a:pPr marL="0" indent="0" algn="l">
+            <a:pPr algn="l" indent="0" marL="0">
               <a:lnSpc>
                 <a:spcPts val="1885"/>
               </a:lnSpc>
@@ -5755,13 +5981,6 @@
             <a:prstDash val="solid"/>
           </a:ln>
         </p:spPr>
-        <p:txBody>
-          <a:bodyPr/>
-          <a:lstStyle/>
-          <a:p>
-            <a:endParaRPr lang="en-US"/>
-          </a:p>
-        </p:txBody>
       </p:sp>
       <p:sp>
         <p:nvSpPr>
@@ -5786,7 +6005,7 @@
           </a:bodyPr>
           <a:lstStyle/>
           <a:p>
-            <a:pPr marL="0" indent="0" algn="l">
+            <a:pPr algn="l" indent="0" marL="0">
               <a:lnSpc>
                 <a:spcPts val="2000"/>
               </a:lnSpc>
@@ -5830,7 +6049,7 @@
           </a:bodyPr>
           <a:lstStyle/>
           <a:p>
-            <a:pPr marL="0" indent="0" algn="l">
+            <a:pPr algn="l" indent="0" marL="0">
               <a:lnSpc>
                 <a:spcPts val="1885"/>
               </a:lnSpc>
@@ -5873,13 +6092,6 @@
             <a:prstDash val="solid"/>
           </a:ln>
         </p:spPr>
-        <p:txBody>
-          <a:bodyPr/>
-          <a:lstStyle/>
-          <a:p>
-            <a:endParaRPr lang="en-US"/>
-          </a:p>
-        </p:txBody>
       </p:sp>
       <p:sp>
         <p:nvSpPr>
@@ -5904,7 +6116,7 @@
           </a:bodyPr>
           <a:lstStyle/>
           <a:p>
-            <a:pPr marL="0" indent="0" algn="l">
+            <a:pPr algn="l" indent="0" marL="0">
               <a:lnSpc>
                 <a:spcPts val="2000"/>
               </a:lnSpc>
@@ -5948,7 +6160,7 @@
           </a:bodyPr>
           <a:lstStyle/>
           <a:p>
-            <a:pPr marL="0" indent="0" algn="l">
+            <a:pPr algn="l" indent="0" marL="0">
               <a:lnSpc>
                 <a:spcPts val="1885"/>
               </a:lnSpc>
@@ -5963,7 +6175,7 @@
                 <a:ea typeface="DM Sans" pitchFamily="34" charset="-122"/>
                 <a:cs typeface="DM Sans" pitchFamily="34" charset="-120"/>
               </a:rPr>
-              <a:t>We’re all gym regulars, so it’s fun to use classification, clustering and association rules on data about something we actually do.</a:t>
+              <a:t>We’re all gym regulars, so it’s fun to use regression, classification, clustering and association rules on data about something we actually do.</a:t>
             </a:r>
             <a:endParaRPr lang="en-US" sz="1300" dirty="0"/>
           </a:p>
@@ -5985,7 +6197,6 @@
         <a:solidFill>
           <a:srgbClr val="14181F"/>
         </a:solidFill>
-        <a:effectLst/>
       </p:bgPr>
     </p:bg>
     <p:spTree>
@@ -6004,15 +6215,15 @@
       </p:grpSpPr>
       <p:pic>
         <p:nvPicPr>
-          <p:cNvPr id="2" name="Image 0" descr="A kettlebell on a gym floor under falling chalk dust"/>
+          <p:cNvPr id="2" name="Image 0" descr="A kettlebell on a gym floor under falling chalk dust">    </p:cNvPr>
           <p:cNvPicPr>
             <a:picLocks noChangeAspect="1"/>
           </p:cNvPicPr>
           <p:nvPr/>
         </p:nvPicPr>
         <p:blipFill>
-          <a:blip r:embed="rId3"/>
-          <a:srcRect l="150" r="150"/>
+          <a:blip r:embed="rId1"/>
+          <a:srcRect l="150" r="150" t="0" b="0"/>
           <a:stretch/>
         </p:blipFill>
         <p:spPr>
@@ -6033,7 +6244,7 @@
         </p:nvSpPr>
         <p:spPr>
           <a:xfrm>
-            <a:off x="0" y="261257"/>
+            <a:off x="0" y="0"/>
             <a:ext cx="12192000" cy="6858000"/>
           </a:xfrm>
           <a:prstGeom prst="rect">
@@ -6061,13 +6272,6 @@
           </a:gradFill>
           <a:ln/>
         </p:spPr>
-        <p:txBody>
-          <a:bodyPr/>
-          <a:lstStyle/>
-          <a:p>
-            <a:endParaRPr lang="en-US"/>
-          </a:p>
-        </p:txBody>
       </p:sp>
       <p:sp>
         <p:nvSpPr>
@@ -6088,13 +6292,6 @@
           </a:solidFill>
           <a:ln/>
         </p:spPr>
-        <p:txBody>
-          <a:bodyPr/>
-          <a:lstStyle/>
-          <a:p>
-            <a:endParaRPr lang="en-US"/>
-          </a:p>
-        </p:txBody>
       </p:sp>
       <p:sp>
         <p:nvSpPr>
@@ -6119,14 +6316,14 @@
           </a:bodyPr>
           <a:lstStyle/>
           <a:p>
-            <a:pPr marL="0" indent="0" algn="l">
+            <a:pPr algn="l" indent="0" marL="0">
               <a:lnSpc>
                 <a:spcPts val="1820"/>
               </a:lnSpc>
               <a:buNone/>
             </a:pPr>
             <a:r>
-              <a:rPr lang="en-US" sz="1300" b="1" kern="0" spc="200" dirty="0">
+              <a:rPr lang="en-US" sz="1300" b="1" spc="200" kern="0" dirty="0">
                 <a:solidFill>
                   <a:srgbClr val="FF6B35"/>
                 </a:solidFill>
@@ -6163,7 +6360,7 @@
           </a:bodyPr>
           <a:lstStyle/>
           <a:p>
-            <a:pPr marL="0" indent="0" algn="l">
+            <a:pPr algn="l" indent="0" marL="0">
               <a:lnSpc>
                 <a:spcPts val="6300"/>
               </a:lnSpc>
@@ -6215,7 +6412,7 @@
           </a:bodyPr>
           <a:lstStyle/>
           <a:p>
-            <a:pPr marL="0" indent="0" algn="l">
+            <a:pPr algn="l" indent="0" marL="0">
               <a:lnSpc>
                 <a:spcPts val="2240"/>
               </a:lnSpc>
@@ -6537,319 +6734,4 @@
     </a:ext>
   </a:extLst>
 </a:theme>
-</file>
-
-<file path=ppt/theme/theme2.xml><?xml version="1.0" encoding="utf-8"?>
-<a:theme xmlns:a="http://schemas.openxmlformats.org/drawingml/2006/main" name="Office Theme">
-  <a:themeElements>
-    <a:clrScheme name="Office">
-      <a:dk1>
-        <a:sysClr val="windowText" lastClr="000000"/>
-      </a:dk1>
-      <a:lt1>
-        <a:sysClr val="window" lastClr="FFFFFF"/>
-      </a:lt1>
-      <a:dk2>
-        <a:srgbClr val="0E2841"/>
-      </a:dk2>
-      <a:lt2>
-        <a:srgbClr val="E8E8E8"/>
-      </a:lt2>
-      <a:accent1>
-        <a:srgbClr val="156082"/>
-      </a:accent1>
-      <a:accent2>
-        <a:srgbClr val="E97132"/>
-      </a:accent2>
-      <a:accent3>
-        <a:srgbClr val="196B24"/>
-      </a:accent3>
-      <a:accent4>
-        <a:srgbClr val="0F9ED5"/>
-      </a:accent4>
-      <a:accent5>
-        <a:srgbClr val="A02B93"/>
-      </a:accent5>
-      <a:accent6>
-        <a:srgbClr val="4EA72E"/>
-      </a:accent6>
-      <a:hlink>
-        <a:srgbClr val="467886"/>
-      </a:hlink>
-      <a:folHlink>
-        <a:srgbClr val="96607D"/>
-      </a:folHlink>
-    </a:clrScheme>
-    <a:fontScheme name="Office">
-      <a:majorFont>
-        <a:latin typeface="Aptos Display" panose="02110004020202020204"/>
-        <a:ea typeface=""/>
-        <a:cs typeface=""/>
-        <a:font script="Jpan" typeface="游ゴシック Light"/>
-        <a:font script="Hang" typeface="맑은 고딕"/>
-        <a:font script="Hans" typeface="等线 Light"/>
-        <a:font script="Hant" typeface="新細明體"/>
-        <a:font script="Arab" typeface="Times New Roman"/>
-        <a:font script="Hebr" typeface="Times New Roman"/>
-        <a:font script="Thai" typeface="Angsana New"/>
-        <a:font script="Ethi" typeface="Nyala"/>
-        <a:font script="Beng" typeface="Vrinda"/>
-        <a:font script="Gujr" typeface="Shruti"/>
-        <a:font script="Khmr" typeface="MoolBoran"/>
-        <a:font script="Knda" typeface="Tunga"/>
-        <a:font script="Guru" typeface="Raavi"/>
-        <a:font script="Cans" typeface="Euphemia"/>
-        <a:font script="Cher" typeface="Plantagenet Cherokee"/>
-        <a:font script="Yiii" typeface="Microsoft Yi Baiti"/>
-        <a:font script="Tibt" typeface="Microsoft Himalaya"/>
-        <a:font script="Thaa" typeface="MV Boli"/>
-        <a:font script="Deva" typeface="Mangal"/>
-        <a:font script="Telu" typeface="Gautami"/>
-        <a:font script="Taml" typeface="Latha"/>
-        <a:font script="Syrc" typeface="Estrangelo Edessa"/>
-        <a:font script="Orya" typeface="Kalinga"/>
-        <a:font script="Mlym" typeface="Kartika"/>
-        <a:font script="Laoo" typeface="DokChampa"/>
-        <a:font script="Sinh" typeface="Iskoola Pota"/>
-        <a:font script="Mong" typeface="Mongolian Baiti"/>
-        <a:font script="Viet" typeface="Times New Roman"/>
-        <a:font script="Uigh" typeface="Microsoft Uighur"/>
-        <a:font script="Geor" typeface="Sylfaen"/>
-        <a:font script="Armn" typeface="Arial"/>
-        <a:font script="Bugi" typeface="Leelawadee UI"/>
-        <a:font script="Bopo" typeface="Microsoft JhengHei"/>
-        <a:font script="Java" typeface="Javanese Text"/>
-        <a:font script="Lisu" typeface="Segoe UI"/>
-        <a:font script="Mymr" typeface="Myanmar Text"/>
-        <a:font script="Nkoo" typeface="Ebrima"/>
-        <a:font script="Olck" typeface="Nirmala UI"/>
-        <a:font script="Osma" typeface="Ebrima"/>
-        <a:font script="Phag" typeface="Phagspa"/>
-        <a:font script="Syrn" typeface="Estrangelo Edessa"/>
-        <a:font script="Syrj" typeface="Estrangelo Edessa"/>
-        <a:font script="Syre" typeface="Estrangelo Edessa"/>
-        <a:font script="Sora" typeface="Nirmala UI"/>
-        <a:font script="Tale" typeface="Microsoft Tai Le"/>
-        <a:font script="Talu" typeface="Microsoft New Tai Lue"/>
-        <a:font script="Tfng" typeface="Ebrima"/>
-      </a:majorFont>
-      <a:minorFont>
-        <a:latin typeface="Aptos" panose="02110004020202020204"/>
-        <a:ea typeface=""/>
-        <a:cs typeface=""/>
-        <a:font script="Jpan" typeface="游ゴシック"/>
-        <a:font script="Hang" typeface="맑은 고딕"/>
-        <a:font script="Hans" typeface="等线"/>
-        <a:font script="Hant" typeface="新細明體"/>
-        <a:font script="Arab" typeface="Arial"/>
-        <a:font script="Hebr" typeface="Arial"/>
-        <a:font script="Thai" typeface="Cordia New"/>
-        <a:font script="Ethi" typeface="Nyala"/>
-        <a:font script="Beng" typeface="Vrinda"/>
-        <a:font script="Gujr" typeface="Shruti"/>
-        <a:font script="Khmr" typeface="DaunPenh"/>
-        <a:font script="Knda" typeface="Tunga"/>
-        <a:font script="Guru" typeface="Raavi"/>
-        <a:font script="Cans" typeface="Euphemia"/>
-        <a:font script="Cher" typeface="Plantagenet Cherokee"/>
-        <a:font script="Yiii" typeface="Microsoft Yi Baiti"/>
-        <a:font script="Tibt" typeface="Microsoft Himalaya"/>
-        <a:font script="Thaa" typeface="MV Boli"/>
-        <a:font script="Deva" typeface="Mangal"/>
-        <a:font script="Telu" typeface="Gautami"/>
-        <a:font script="Taml" typeface="Latha"/>
-        <a:font script="Syrc" typeface="Estrangelo Edessa"/>
-        <a:font script="Orya" typeface="Kalinga"/>
-        <a:font script="Mlym" typeface="Kartika"/>
-        <a:font script="Laoo" typeface="DokChampa"/>
-        <a:font script="Sinh" typeface="Iskoola Pota"/>
-        <a:font script="Mong" typeface="Mongolian Baiti"/>
-        <a:font script="Viet" typeface="Arial"/>
-        <a:font script="Uigh" typeface="Microsoft Uighur"/>
-        <a:font script="Geor" typeface="Sylfaen"/>
-        <a:font script="Armn" typeface="Arial"/>
-        <a:font script="Bugi" typeface="Leelawadee UI"/>
-        <a:font script="Bopo" typeface="Microsoft JhengHei"/>
-        <a:font script="Java" typeface="Javanese Text"/>
-        <a:font script="Lisu" typeface="Segoe UI"/>
-        <a:font script="Mymr" typeface="Myanmar Text"/>
-        <a:font script="Nkoo" typeface="Ebrima"/>
-        <a:font script="Olck" typeface="Nirmala UI"/>
-        <a:font script="Osma" typeface="Ebrima"/>
-        <a:font script="Phag" typeface="Phagspa"/>
-        <a:font script="Syrn" typeface="Estrangelo Edessa"/>
-        <a:font script="Syrj" typeface="Estrangelo Edessa"/>
-        <a:font script="Syre" typeface="Estrangelo Edessa"/>
-        <a:font script="Sora" typeface="Nirmala UI"/>
-        <a:font script="Tale" typeface="Microsoft Tai Le"/>
-        <a:font script="Talu" typeface="Microsoft New Tai Lue"/>
-        <a:font script="Tfng" typeface="Ebrima"/>
-      </a:minorFont>
-    </a:fontScheme>
-    <a:fmtScheme name="Office">
-      <a:fillStyleLst>
-        <a:solidFill>
-          <a:schemeClr val="phClr"/>
-        </a:solidFill>
-        <a:gradFill rotWithShape="1">
-          <a:gsLst>
-            <a:gs pos="0">
-              <a:schemeClr val="phClr">
-                <a:lumMod val="110000"/>
-                <a:satMod val="105000"/>
-                <a:tint val="67000"/>
-              </a:schemeClr>
-            </a:gs>
-            <a:gs pos="50000">
-              <a:schemeClr val="phClr">
-                <a:lumMod val="105000"/>
-                <a:satMod val="103000"/>
-                <a:tint val="73000"/>
-              </a:schemeClr>
-            </a:gs>
-            <a:gs pos="100000">
-              <a:schemeClr val="phClr">
-                <a:lumMod val="105000"/>
-                <a:satMod val="109000"/>
-                <a:tint val="81000"/>
-              </a:schemeClr>
-            </a:gs>
-          </a:gsLst>
-          <a:lin ang="5400000" scaled="0"/>
-        </a:gradFill>
-        <a:gradFill rotWithShape="1">
-          <a:gsLst>
-            <a:gs pos="0">
-              <a:schemeClr val="phClr">
-                <a:satMod val="103000"/>
-                <a:lumMod val="102000"/>
-                <a:tint val="94000"/>
-              </a:schemeClr>
-            </a:gs>
-            <a:gs pos="50000">
-              <a:schemeClr val="phClr">
-                <a:satMod val="110000"/>
-                <a:lumMod val="100000"/>
-                <a:shade val="100000"/>
-              </a:schemeClr>
-            </a:gs>
-            <a:gs pos="100000">
-              <a:schemeClr val="phClr">
-                <a:lumMod val="99000"/>
-                <a:satMod val="120000"/>
-                <a:shade val="78000"/>
-              </a:schemeClr>
-            </a:gs>
-          </a:gsLst>
-          <a:lin ang="5400000" scaled="0"/>
-        </a:gradFill>
-      </a:fillStyleLst>
-      <a:lnStyleLst>
-        <a:ln w="12700" cap="flat" cmpd="sng" algn="ctr">
-          <a:solidFill>
-            <a:schemeClr val="phClr"/>
-          </a:solidFill>
-          <a:prstDash val="solid"/>
-          <a:miter lim="800000"/>
-        </a:ln>
-        <a:ln w="19050" cap="flat" cmpd="sng" algn="ctr">
-          <a:solidFill>
-            <a:schemeClr val="phClr"/>
-          </a:solidFill>
-          <a:prstDash val="solid"/>
-          <a:miter lim="800000"/>
-        </a:ln>
-        <a:ln w="25400" cap="flat" cmpd="sng" algn="ctr">
-          <a:solidFill>
-            <a:schemeClr val="phClr"/>
-          </a:solidFill>
-          <a:prstDash val="solid"/>
-          <a:miter lim="800000"/>
-        </a:ln>
-      </a:lnStyleLst>
-      <a:effectStyleLst>
-        <a:effectStyle>
-          <a:effectLst/>
-        </a:effectStyle>
-        <a:effectStyle>
-          <a:effectLst/>
-        </a:effectStyle>
-        <a:effectStyle>
-          <a:effectLst>
-            <a:outerShdw blurRad="57150" dist="19050" dir="5400000" algn="ctr" rotWithShape="0">
-              <a:srgbClr val="000000">
-                <a:alpha val="63000"/>
-              </a:srgbClr>
-            </a:outerShdw>
-          </a:effectLst>
-        </a:effectStyle>
-      </a:effectStyleLst>
-      <a:bgFillStyleLst>
-        <a:solidFill>
-          <a:schemeClr val="phClr"/>
-        </a:solidFill>
-        <a:solidFill>
-          <a:schemeClr val="phClr">
-            <a:tint val="95000"/>
-            <a:satMod val="170000"/>
-          </a:schemeClr>
-        </a:solidFill>
-        <a:gradFill rotWithShape="1">
-          <a:gsLst>
-            <a:gs pos="0">
-              <a:schemeClr val="phClr">
-                <a:tint val="93000"/>
-                <a:satMod val="150000"/>
-                <a:shade val="98000"/>
-                <a:lumMod val="102000"/>
-              </a:schemeClr>
-            </a:gs>
-            <a:gs pos="50000">
-              <a:schemeClr val="phClr">
-                <a:tint val="98000"/>
-                <a:satMod val="130000"/>
-                <a:shade val="90000"/>
-                <a:lumMod val="103000"/>
-              </a:schemeClr>
-            </a:gs>
-            <a:gs pos="100000">
-              <a:schemeClr val="phClr">
-                <a:shade val="63000"/>
-                <a:satMod val="120000"/>
-              </a:schemeClr>
-            </a:gs>
-          </a:gsLst>
-          <a:lin ang="5400000" scaled="0"/>
-        </a:gradFill>
-      </a:bgFillStyleLst>
-    </a:fmtScheme>
-  </a:themeElements>
-  <a:objectDefaults>
-    <a:lnDef>
-      <a:spPr/>
-      <a:bodyPr/>
-      <a:lstStyle/>
-      <a:style>
-        <a:lnRef idx="2">
-          <a:schemeClr val="accent1"/>
-        </a:lnRef>
-        <a:fillRef idx="0">
-          <a:schemeClr val="accent1"/>
-        </a:fillRef>
-        <a:effectRef idx="1">
-          <a:schemeClr val="accent1"/>
-        </a:effectRef>
-        <a:fontRef idx="minor">
-          <a:schemeClr val="tx1"/>
-        </a:fontRef>
-      </a:style>
-    </a:lnDef>
-  </a:objectDefaults>
-  <a:extraClrSchemeLst/>
-  <a:extLst>
-    <a:ext uri="{05A4C25C-085E-4340-85A3-A5531E510DB2}">
-      <thm15:themeFamily xmlns:thm15="http://schemas.microsoft.com/office/thememl/2012/main" name="Office Theme" id="{2E142A2C-CD16-42D6-873A-C26D2A0506FA}" vid="{1BDDFF52-6CD6-40A5-AB3C-68EB2F1E4D0A}"/>
-    </a:ext>
-  </a:extLst>
-</a:theme>
 </file>
</xml_diff>